<commit_message>
Add slide 2: campaign performance tracking slide (layout structure adapted from reference template, rebuilt with Exabeam data and native charts)
</commit_message>
<xml_diff>
--- a/Insider_Threat_Campaign_Scorecard.pptx
+++ b/Insider_Threat_Campaign_Scorecard.pptx
@@ -6,6 +6,7 @@
   </p:sldMasterIdLst>
   <p:sldIdLst>
     <p:sldId id="256" r:id="rId7"/>
+    <p:sldId id="257" r:id="rId8"/>
   </p:sldIdLst>
   <p:sldSz cx="12191695" cy="6858000" type="screen4x3"/>
   <p:notesSz cx="6858000" cy="9144000"/>
@@ -105,6 +106,404 @@
     </a:lvl9pPr>
   </p:defaultTextStyle>
 </p:presentation>
+</file>
+
+<file path=ppt/charts/chart1.xml><?xml version="1.0" encoding="utf-8"?>
+<c:chartSpace xmlns:c="http://schemas.openxmlformats.org/drawingml/2006/chart" xmlns:a="http://schemas.openxmlformats.org/drawingml/2006/main" xmlns:r="http://schemas.openxmlformats.org/officeDocument/2006/relationships">
+  <c:date1904 val="0"/>
+  <c:chart>
+    <c:autoTitleDeleted val="1"/>
+    <c:plotArea>
+      <c:lineChart>
+        <c:grouping val="standard"/>
+        <c:varyColors val="0"/>
+        <c:ser>
+          <c:idx val="0"/>
+          <c:order val="0"/>
+          <c:tx>
+            <c:strRef>
+              <c:f>Sheet1!$B$1</c:f>
+              <c:strCache>
+                <c:ptCount val="1"/>
+                <c:pt idx="0">
+                  <c:v>Leads</c:v>
+                </c:pt>
+              </c:strCache>
+            </c:strRef>
+          </c:tx>
+          <c:spPr>
+            <a:ln w="28575">
+              <a:solidFill>
+                <a:srgbClr val="006BFF"/>
+              </a:solidFill>
+            </a:ln>
+          </c:spPr>
+          <c:marker>
+            <c:size val="5"/>
+            <c:spPr>
+              <a:solidFill>
+                <a:srgbClr val="006BFF"/>
+              </a:solidFill>
+            </c:spPr>
+          </c:marker>
+          <c:cat>
+            <c:strRef>
+              <c:f>Sheet1!$A$2:$A$14</c:f>
+              <c:strCache>
+                <c:ptCount val="13"/>
+                <c:pt idx="0">
+                  <c:v>W1</c:v>
+                </c:pt>
+                <c:pt idx="1">
+                  <c:v>W2</c:v>
+                </c:pt>
+                <c:pt idx="2">
+                  <c:v>W3</c:v>
+                </c:pt>
+                <c:pt idx="3">
+                  <c:v>W4</c:v>
+                </c:pt>
+                <c:pt idx="4">
+                  <c:v>W5</c:v>
+                </c:pt>
+                <c:pt idx="5">
+                  <c:v>W6</c:v>
+                </c:pt>
+                <c:pt idx="6">
+                  <c:v>W7</c:v>
+                </c:pt>
+                <c:pt idx="7">
+                  <c:v>W8</c:v>
+                </c:pt>
+                <c:pt idx="8">
+                  <c:v>W9</c:v>
+                </c:pt>
+                <c:pt idx="9">
+                  <c:v>W10</c:v>
+                </c:pt>
+                <c:pt idx="10">
+                  <c:v>W11</c:v>
+                </c:pt>
+                <c:pt idx="11">
+                  <c:v>W12</c:v>
+                </c:pt>
+                <c:pt idx="12">
+                  <c:v>W13</c:v>
+                </c:pt>
+              </c:strCache>
+            </c:strRef>
+          </c:cat>
+          <c:val>
+            <c:numRef>
+              <c:f>Sheet1!$B$2:$B$14</c:f>
+              <c:numCache>
+                <c:formatCode>General</c:formatCode>
+                <c:ptCount val="13"/>
+                <c:pt idx="0">
+                  <c:v>140</c:v>
+                </c:pt>
+                <c:pt idx="1">
+                  <c:v>205</c:v>
+                </c:pt>
+                <c:pt idx="2">
+                  <c:v>260</c:v>
+                </c:pt>
+                <c:pt idx="3">
+                  <c:v>310</c:v>
+                </c:pt>
+                <c:pt idx="4">
+                  <c:v>295</c:v>
+                </c:pt>
+                <c:pt idx="5">
+                  <c:v>340</c:v>
+                </c:pt>
+                <c:pt idx="6">
+                  <c:v>380</c:v>
+                </c:pt>
+                <c:pt idx="7">
+                  <c:v>410</c:v>
+                </c:pt>
+                <c:pt idx="8">
+                  <c:v>455</c:v>
+                </c:pt>
+                <c:pt idx="9">
+                  <c:v>420</c:v>
+                </c:pt>
+                <c:pt idx="10">
+                  <c:v>470</c:v>
+                </c:pt>
+                <c:pt idx="11">
+                  <c:v>510</c:v>
+                </c:pt>
+                <c:pt idx="12">
+                  <c:v>490</c:v>
+                </c:pt>
+              </c:numCache>
+            </c:numRef>
+          </c:val>
+          <c:smooth val="0"/>
+        </c:ser>
+        <c:marker val="1"/>
+        <c:smooth val="0"/>
+        <c:axId val="2118791784"/>
+        <c:axId val="2140495176"/>
+      </c:lineChart>
+      <c:catAx>
+        <c:axId val="2118791784"/>
+        <c:scaling>
+          <c:orientation val="minMax"/>
+        </c:scaling>
+        <c:delete val="0"/>
+        <c:axPos val="b"/>
+        <c:majorTickMark val="out"/>
+        <c:minorTickMark val="none"/>
+        <c:tickLblPos val="nextTo"/>
+        <c:spPr>
+          <a:ln>
+            <a:solidFill>
+              <a:srgbClr val="E0E0E0"/>
+            </a:solidFill>
+          </a:ln>
+        </c:spPr>
+        <c:txPr>
+          <a:bodyPr/>
+          <a:lstStyle/>
+          <a:p>
+            <a:pPr>
+              <a:defRPr sz="750"/>
+            </a:pPr>
+          </a:p>
+        </c:txPr>
+        <c:crossAx val="2140495176"/>
+        <c:crosses val="autoZero"/>
+        <c:auto val="1"/>
+        <c:lblAlgn val="ctr"/>
+        <c:lblOffset val="100"/>
+        <c:noMultiLvlLbl val="0"/>
+      </c:catAx>
+      <c:valAx>
+        <c:axId val="2140495176"/>
+        <c:scaling/>
+        <c:delete val="0"/>
+        <c:axPos val="l"/>
+        <c:majorGridlines>
+          <c:spPr>
+            <a:ln w="6350">
+              <a:solidFill>
+                <a:srgbClr val="E0E0E0"/>
+              </a:solidFill>
+            </a:ln>
+          </c:spPr>
+        </c:majorGridlines>
+        <c:majorTickMark val="out"/>
+        <c:minorTickMark val="none"/>
+        <c:tickLblPos val="nextTo"/>
+        <c:spPr>
+          <a:ln>
+            <a:solidFill>
+              <a:srgbClr val="E0E0E0"/>
+            </a:solidFill>
+          </a:ln>
+        </c:spPr>
+        <c:txPr>
+          <a:bodyPr/>
+          <a:lstStyle/>
+          <a:p>
+            <a:pPr>
+              <a:defRPr sz="750"/>
+            </a:pPr>
+          </a:p>
+        </c:txPr>
+        <c:crossAx val="2118791784"/>
+        <c:crosses val="autoZero"/>
+      </c:valAx>
+    </c:plotArea>
+    <c:plotVisOnly val="1"/>
+    <c:dispBlanksAs val="gap"/>
+    <c:showDLblsOverMax val="0"/>
+  </c:chart>
+  <c:txPr>
+    <a:bodyPr/>
+    <a:lstStyle/>
+    <a:p>
+      <a:pPr>
+        <a:defRPr sz="1800"/>
+      </a:pPr>
+      <a:endParaRPr lang="en-US"/>
+    </a:p>
+  </c:txPr>
+  <c:externalData r:id="rId1">
+    <c:autoUpdate val="0"/>
+  </c:externalData>
+</c:chartSpace>
+</file>
+
+<file path=ppt/charts/chart2.xml><?xml version="1.0" encoding="utf-8"?>
+<c:chartSpace xmlns:c="http://schemas.openxmlformats.org/drawingml/2006/chart" xmlns:a="http://schemas.openxmlformats.org/drawingml/2006/main" xmlns:r="http://schemas.openxmlformats.org/officeDocument/2006/relationships">
+  <c:date1904 val="0"/>
+  <c:chart>
+    <c:autoTitleDeleted val="1"/>
+    <c:plotArea>
+      <c:barChart>
+        <c:barDir val="bar"/>
+        <c:grouping val="clustered"/>
+        <c:ser>
+          <c:idx val="0"/>
+          <c:order val="0"/>
+          <c:tx>
+            <c:strRef>
+              <c:f>Sheet1!$B$1</c:f>
+              <c:strCache>
+                <c:ptCount val="1"/>
+                <c:pt idx="0">
+                  <c:v>Count</c:v>
+                </c:pt>
+              </c:strCache>
+            </c:strRef>
+          </c:tx>
+          <c:spPr>
+            <a:solidFill>
+              <a:srgbClr val="009D00"/>
+            </a:solidFill>
+          </c:spPr>
+          <c:cat>
+            <c:strRef>
+              <c:f>Sheet1!$A$2:$A$6</c:f>
+              <c:strCache>
+                <c:ptCount val="5"/>
+                <c:pt idx="0">
+                  <c:v>Inquiry</c:v>
+                </c:pt>
+                <c:pt idx="1">
+                  <c:v>MQL</c:v>
+                </c:pt>
+                <c:pt idx="2">
+                  <c:v>SQL</c:v>
+                </c:pt>
+                <c:pt idx="3">
+                  <c:v>Opportunity</c:v>
+                </c:pt>
+                <c:pt idx="4">
+                  <c:v>Won</c:v>
+                </c:pt>
+              </c:strCache>
+            </c:strRef>
+          </c:cat>
+          <c:val>
+            <c:numRef>
+              <c:f>Sheet1!$B$2:$B$6</c:f>
+              <c:numCache>
+                <c:formatCode>General</c:formatCode>
+                <c:ptCount val="5"/>
+                <c:pt idx="0">
+                  <c:v>3842</c:v>
+                </c:pt>
+                <c:pt idx="1">
+                  <c:v>1120</c:v>
+                </c:pt>
+                <c:pt idx="2">
+                  <c:v>412</c:v>
+                </c:pt>
+                <c:pt idx="3">
+                  <c:v>214</c:v>
+                </c:pt>
+                <c:pt idx="4">
+                  <c:v>38</c:v>
+                </c:pt>
+              </c:numCache>
+            </c:numRef>
+          </c:val>
+        </c:ser>
+        <c:gapWidth val="40"/>
+        <c:axId val="-2068027336"/>
+        <c:axId val="-2113994440"/>
+      </c:barChart>
+      <c:catAx>
+        <c:axId val="-2068027336"/>
+        <c:scaling>
+          <c:orientation val="minMax"/>
+        </c:scaling>
+        <c:delete val="0"/>
+        <c:axPos val="l"/>
+        <c:majorTickMark val="out"/>
+        <c:minorTickMark val="none"/>
+        <c:tickLblPos val="nextTo"/>
+        <c:spPr>
+          <a:ln>
+            <a:solidFill>
+              <a:srgbClr val="E0E0E0"/>
+            </a:solidFill>
+          </a:ln>
+        </c:spPr>
+        <c:txPr>
+          <a:bodyPr/>
+          <a:lstStyle/>
+          <a:p>
+            <a:pPr>
+              <a:defRPr sz="800"/>
+            </a:pPr>
+          </a:p>
+        </c:txPr>
+        <c:crossAx val="-2113994440"/>
+        <c:crosses val="autoZero"/>
+        <c:auto val="1"/>
+        <c:lblAlgn val="ctr"/>
+        <c:lblOffset val="100"/>
+        <c:noMultiLvlLbl val="0"/>
+      </c:catAx>
+      <c:valAx>
+        <c:axId val="-2113994440"/>
+        <c:scaling/>
+        <c:delete val="0"/>
+        <c:axPos val="b"/>
+        <c:majorGridlines>
+          <c:spPr>
+            <a:ln w="6350">
+              <a:solidFill>
+                <a:srgbClr val="E0E0E0"/>
+              </a:solidFill>
+            </a:ln>
+          </c:spPr>
+        </c:majorGridlines>
+        <c:majorTickMark val="out"/>
+        <c:minorTickMark val="none"/>
+        <c:tickLblPos val="nextTo"/>
+        <c:spPr>
+          <a:ln>
+            <a:solidFill>
+              <a:srgbClr val="E0E0E0"/>
+            </a:solidFill>
+          </a:ln>
+        </c:spPr>
+        <c:txPr>
+          <a:bodyPr/>
+          <a:lstStyle/>
+          <a:p>
+            <a:pPr>
+              <a:defRPr sz="750"/>
+            </a:pPr>
+          </a:p>
+        </c:txPr>
+        <c:crossAx val="-2068027336"/>
+        <c:crosses val="autoZero"/>
+      </c:valAx>
+    </c:plotArea>
+    <c:dispBlanksAs val="gap"/>
+  </c:chart>
+  <c:txPr>
+    <a:bodyPr/>
+    <a:lstStyle/>
+    <a:p>
+      <a:pPr>
+        <a:defRPr sz="1800"/>
+      </a:pPr>
+      <a:endParaRPr lang="en-US"/>
+    </a:p>
+  </c:txPr>
+  <c:externalData r:id="rId1">
+    <c:autoUpdate val="0"/>
+  </c:externalData>
+</c:chartSpace>
 </file>
 
 <file path=ppt/slideLayouts/slideLayout1.xml><?xml version="1.0" encoding="utf-8"?>
@@ -5832,6 +6231,2974 @@
                 <a:latin typeface="Arial"/>
               </a:rPr>
               <a:t>Page 1 of 2</a:t>
+            </a:r>
+          </a:p>
+        </p:txBody>
+      </p:sp>
+    </p:spTree>
+  </p:cSld>
+  <p:clrMapOvr>
+    <a:masterClrMapping/>
+  </p:clrMapOvr>
+</p:sld>
+</file>
+
+<file path=ppt/slides/slide2.xml><?xml version="1.0" encoding="utf-8"?>
+<p:sld xmlns:a="http://schemas.openxmlformats.org/drawingml/2006/main" xmlns:p="http://schemas.openxmlformats.org/presentationml/2006/main" xmlns:r="http://schemas.openxmlformats.org/officeDocument/2006/relationships">
+  <p:cSld>
+    <p:spTree>
+      <p:nvGrpSpPr>
+        <p:cNvPr id="1" name=""/>
+        <p:cNvGrpSpPr/>
+        <p:nvPr/>
+      </p:nvGrpSpPr>
+      <p:grpSpPr/>
+      <p:sp>
+        <p:nvSpPr>
+          <p:cNvPr id="2" name="Rectangle 1"/>
+          <p:cNvSpPr/>
+          <p:nvPr/>
+        </p:nvSpPr>
+        <p:spPr>
+          <a:xfrm>
+            <a:off x="0" y="0"/>
+            <a:ext cx="12191695" cy="6858000"/>
+          </a:xfrm>
+          <a:prstGeom prst="rect">
+            <a:avLst/>
+          </a:prstGeom>
+          <a:solidFill>
+            <a:srgbClr val="FFFFFF"/>
+          </a:solidFill>
+          <a:ln>
+            <a:noFill/>
+          </a:ln>
+          <a:effectLst/>
+        </p:spPr>
+        <p:style>
+          <a:lnRef idx="1">
+            <a:schemeClr val="accent1"/>
+          </a:lnRef>
+          <a:fillRef idx="3">
+            <a:schemeClr val="accent1"/>
+          </a:fillRef>
+          <a:effectRef idx="2">
+            <a:schemeClr val="accent1"/>
+          </a:effectRef>
+          <a:fontRef idx="minor">
+            <a:schemeClr val="lt1"/>
+          </a:fontRef>
+        </p:style>
+        <p:txBody>
+          <a:bodyPr rtlCol="0" anchor="ctr"/>
+          <a:lstStyle/>
+          <a:p>
+            <a:pPr algn="ctr"/>
+          </a:p>
+        </p:txBody>
+      </p:sp>
+      <p:sp>
+        <p:nvSpPr>
+          <p:cNvPr id="3" name="Rectangle 2"/>
+          <p:cNvSpPr/>
+          <p:nvPr/>
+        </p:nvSpPr>
+        <p:spPr>
+          <a:xfrm>
+            <a:off x="0" y="0"/>
+            <a:ext cx="12191695" cy="777240"/>
+          </a:xfrm>
+          <a:prstGeom prst="rect">
+            <a:avLst/>
+          </a:prstGeom>
+          <a:solidFill>
+            <a:srgbClr val="0A0A0A"/>
+          </a:solidFill>
+          <a:ln>
+            <a:noFill/>
+          </a:ln>
+          <a:effectLst/>
+        </p:spPr>
+        <p:style>
+          <a:lnRef idx="1">
+            <a:schemeClr val="accent1"/>
+          </a:lnRef>
+          <a:fillRef idx="3">
+            <a:schemeClr val="accent1"/>
+          </a:fillRef>
+          <a:effectRef idx="2">
+            <a:schemeClr val="accent1"/>
+          </a:effectRef>
+          <a:fontRef idx="minor">
+            <a:schemeClr val="lt1"/>
+          </a:fontRef>
+        </p:style>
+        <p:txBody>
+          <a:bodyPr rtlCol="0" anchor="ctr"/>
+          <a:lstStyle/>
+          <a:p>
+            <a:pPr algn="ctr"/>
+          </a:p>
+        </p:txBody>
+      </p:sp>
+      <p:sp>
+        <p:nvSpPr>
+          <p:cNvPr id="4" name="TextBox 3"/>
+          <p:cNvSpPr txBox="1"/>
+          <p:nvPr/>
+        </p:nvSpPr>
+        <p:spPr>
+          <a:xfrm>
+            <a:off x="502920" y="128016"/>
+            <a:ext cx="8686800" cy="365760"/>
+          </a:xfrm>
+          <a:prstGeom prst="rect">
+            <a:avLst/>
+          </a:prstGeom>
+          <a:noFill/>
+        </p:spPr>
+        <p:txBody>
+          <a:bodyPr wrap="square" anchor="t" lIns="0" rIns="0" tIns="0" bIns="0">
+            <a:spAutoFit/>
+          </a:bodyPr>
+          <a:lstStyle/>
+          <a:p>
+            <a:pPr algn="l"/>
+            <a:r>
+              <a:rPr sz="1700" b="1" i="0" spc="30">
+                <a:solidFill>
+                  <a:srgbClr val="FFFFFF"/>
+                </a:solidFill>
+                <a:latin typeface="Arial"/>
+              </a:rPr>
+              <a:t>INSIDER THREAT CAMPAIGN — PERFORMANCE TRACKING</a:t>
+            </a:r>
+          </a:p>
+        </p:txBody>
+      </p:sp>
+      <p:sp>
+        <p:nvSpPr>
+          <p:cNvPr id="5" name="TextBox 4"/>
+          <p:cNvSpPr txBox="1"/>
+          <p:nvPr/>
+        </p:nvSpPr>
+        <p:spPr>
+          <a:xfrm>
+            <a:off x="502920" y="457200"/>
+            <a:ext cx="8686800" cy="274320"/>
+          </a:xfrm>
+          <a:prstGeom prst="rect">
+            <a:avLst/>
+          </a:prstGeom>
+          <a:noFill/>
+        </p:spPr>
+        <p:txBody>
+          <a:bodyPr wrap="square" anchor="t" lIns="0" rIns="0" tIns="0" bIns="0">
+            <a:spAutoFit/>
+          </a:bodyPr>
+          <a:lstStyle/>
+          <a:p>
+            <a:pPr algn="l"/>
+            <a:r>
+              <a:rPr sz="1050" b="0" i="0">
+                <a:solidFill>
+                  <a:srgbClr val="C9C8DE"/>
+                </a:solidFill>
+                <a:latin typeface="Arial"/>
+              </a:rPr>
+              <a:t>Source: Campaign Dashboard  ·  Data as of Oct 1, 2026</a:t>
+            </a:r>
+          </a:p>
+        </p:txBody>
+      </p:sp>
+      <p:sp>
+        <p:nvSpPr>
+          <p:cNvPr id="6" name="Rounded Rectangle 5"/>
+          <p:cNvSpPr/>
+          <p:nvPr/>
+        </p:nvSpPr>
+        <p:spPr>
+          <a:xfrm>
+            <a:off x="365760" y="932688"/>
+            <a:ext cx="2514600" cy="1234440"/>
+          </a:xfrm>
+          <a:prstGeom prst="roundRect">
+            <a:avLst>
+              <a:gd name="adj" fmla="val 6000"/>
+            </a:avLst>
+          </a:prstGeom>
+          <a:solidFill>
+            <a:srgbClr val="F5F5F5"/>
+          </a:solidFill>
+          <a:ln>
+            <a:noFill/>
+          </a:ln>
+          <a:effectLst/>
+        </p:spPr>
+        <p:style>
+          <a:lnRef idx="1">
+            <a:schemeClr val="accent1"/>
+          </a:lnRef>
+          <a:fillRef idx="3">
+            <a:schemeClr val="accent1"/>
+          </a:fillRef>
+          <a:effectRef idx="2">
+            <a:schemeClr val="accent1"/>
+          </a:effectRef>
+          <a:fontRef idx="minor">
+            <a:schemeClr val="lt1"/>
+          </a:fontRef>
+        </p:style>
+        <p:txBody>
+          <a:bodyPr rtlCol="0" anchor="ctr"/>
+          <a:lstStyle/>
+          <a:p>
+            <a:pPr algn="ctr"/>
+          </a:p>
+        </p:txBody>
+      </p:sp>
+      <p:sp>
+        <p:nvSpPr>
+          <p:cNvPr id="7" name="TextBox 6"/>
+          <p:cNvSpPr txBox="1"/>
+          <p:nvPr/>
+        </p:nvSpPr>
+        <p:spPr>
+          <a:xfrm>
+            <a:off x="530352" y="1042416"/>
+            <a:ext cx="2194560" cy="256032"/>
+          </a:xfrm>
+          <a:prstGeom prst="rect">
+            <a:avLst/>
+          </a:prstGeom>
+          <a:noFill/>
+        </p:spPr>
+        <p:txBody>
+          <a:bodyPr wrap="square" anchor="t" lIns="0" rIns="0" tIns="0" bIns="0">
+            <a:spAutoFit/>
+          </a:bodyPr>
+          <a:lstStyle/>
+          <a:p>
+            <a:pPr algn="l"/>
+            <a:r>
+              <a:rPr sz="950" b="1" i="0" spc="10">
+                <a:solidFill>
+                  <a:srgbClr val="706E6B"/>
+                </a:solidFill>
+                <a:latin typeface="Arial"/>
+              </a:rPr>
+              <a:t>PLAN ASSUMPTIONS</a:t>
+            </a:r>
+          </a:p>
+        </p:txBody>
+      </p:sp>
+      <p:sp>
+        <p:nvSpPr>
+          <p:cNvPr id="8" name="TextBox 7"/>
+          <p:cNvSpPr txBox="1"/>
+          <p:nvPr/>
+        </p:nvSpPr>
+        <p:spPr>
+          <a:xfrm>
+            <a:off x="530352" y="1335024"/>
+            <a:ext cx="2194560" cy="237744"/>
+          </a:xfrm>
+          <a:prstGeom prst="rect">
+            <a:avLst/>
+          </a:prstGeom>
+          <a:noFill/>
+        </p:spPr>
+        <p:txBody>
+          <a:bodyPr wrap="square" anchor="t" lIns="0" rIns="0" tIns="0" bIns="0">
+            <a:spAutoFit/>
+          </a:bodyPr>
+          <a:lstStyle/>
+          <a:p>
+            <a:pPr algn="l"/>
+            <a:r>
+              <a:rPr sz="1050" b="0" i="0">
+                <a:solidFill>
+                  <a:srgbClr val="0A0A0A"/>
+                </a:solidFill>
+                <a:latin typeface="Arial"/>
+              </a:rPr>
+              <a:t>Avg Deal Size: ~$22.4K</a:t>
+            </a:r>
+          </a:p>
+        </p:txBody>
+      </p:sp>
+      <p:sp>
+        <p:nvSpPr>
+          <p:cNvPr id="9" name="TextBox 8"/>
+          <p:cNvSpPr txBox="1"/>
+          <p:nvPr/>
+        </p:nvSpPr>
+        <p:spPr>
+          <a:xfrm>
+            <a:off x="530352" y="1591056"/>
+            <a:ext cx="2194560" cy="237744"/>
+          </a:xfrm>
+          <a:prstGeom prst="rect">
+            <a:avLst/>
+          </a:prstGeom>
+          <a:noFill/>
+        </p:spPr>
+        <p:txBody>
+          <a:bodyPr wrap="square" anchor="t" lIns="0" rIns="0" tIns="0" bIns="0">
+            <a:spAutoFit/>
+          </a:bodyPr>
+          <a:lstStyle/>
+          <a:p>
+            <a:pPr algn="l"/>
+            <a:r>
+              <a:rPr sz="1050" b="0" i="0">
+                <a:solidFill>
+                  <a:srgbClr val="0A0A0A"/>
+                </a:solidFill>
+                <a:latin typeface="Arial"/>
+              </a:rPr>
+              <a:t>Lead → MQL: 29.2%</a:t>
+            </a:r>
+          </a:p>
+        </p:txBody>
+      </p:sp>
+      <p:sp>
+        <p:nvSpPr>
+          <p:cNvPr id="10" name="TextBox 9"/>
+          <p:cNvSpPr txBox="1"/>
+          <p:nvPr/>
+        </p:nvSpPr>
+        <p:spPr>
+          <a:xfrm>
+            <a:off x="530352" y="1847088"/>
+            <a:ext cx="2194560" cy="237744"/>
+          </a:xfrm>
+          <a:prstGeom prst="rect">
+            <a:avLst/>
+          </a:prstGeom>
+          <a:noFill/>
+        </p:spPr>
+        <p:txBody>
+          <a:bodyPr wrap="square" anchor="t" lIns="0" rIns="0" tIns="0" bIns="0">
+            <a:spAutoFit/>
+          </a:bodyPr>
+          <a:lstStyle/>
+          <a:p>
+            <a:pPr algn="l"/>
+            <a:r>
+              <a:rPr sz="1050" b="0" i="0">
+                <a:solidFill>
+                  <a:srgbClr val="0A0A0A"/>
+                </a:solidFill>
+                <a:latin typeface="Arial"/>
+              </a:rPr>
+              <a:t>MQL → Opportunity: 19.1%</a:t>
+            </a:r>
+          </a:p>
+        </p:txBody>
+      </p:sp>
+      <p:sp>
+        <p:nvSpPr>
+          <p:cNvPr id="11" name="TextBox 10"/>
+          <p:cNvSpPr txBox="1"/>
+          <p:nvPr/>
+        </p:nvSpPr>
+        <p:spPr>
+          <a:xfrm>
+            <a:off x="3063240" y="914400"/>
+            <a:ext cx="2743200" cy="219456"/>
+          </a:xfrm>
+          <a:prstGeom prst="rect">
+            <a:avLst/>
+          </a:prstGeom>
+          <a:noFill/>
+        </p:spPr>
+        <p:txBody>
+          <a:bodyPr wrap="square" anchor="t" lIns="0" rIns="0" tIns="0" bIns="0">
+            <a:spAutoFit/>
+          </a:bodyPr>
+          <a:lstStyle/>
+          <a:p>
+            <a:pPr algn="l"/>
+            <a:r>
+              <a:rPr sz="950" b="1" i="0" spc="10">
+                <a:solidFill>
+                  <a:srgbClr val="706E6B"/>
+                </a:solidFill>
+                <a:latin typeface="Arial"/>
+              </a:rPr>
+              <a:t>PLAN TARGETS</a:t>
+            </a:r>
+          </a:p>
+        </p:txBody>
+      </p:sp>
+      <p:graphicFrame>
+        <p:nvGraphicFramePr>
+          <p:cNvPr id="12" name="Table 11"/>
+          <p:cNvGraphicFramePr>
+            <a:graphicFrameLocks noGrp="1"/>
+          </p:cNvGraphicFramePr>
+          <p:nvPr/>
+        </p:nvGraphicFramePr>
+        <p:xfrm>
+          <a:off x="3063240" y="1115568"/>
+          <a:ext cx="5394960" cy="1051560"/>
+        </p:xfrm>
+        <a:graphic>
+          <a:graphicData uri="http://schemas.openxmlformats.org/drawingml/2006/table">
+            <a:tbl>
+              <a:tblPr firstRow="1" bandRow="1">
+                <a:tableStyleId>{5C22544A-7EE6-4342-B048-85BDC9FD1C3A}</a:tableStyleId>
+              </a:tblPr>
+              <a:tblGrid>
+                <a:gridCol w="1554480"/>
+                <a:gridCol w="1280160"/>
+                <a:gridCol w="1280160"/>
+                <a:gridCol w="1280160"/>
+              </a:tblGrid>
+              <a:tr h="210312">
+                <a:tc>
+                  <a:txBody>
+                    <a:bodyPr/>
+                    <a:lstStyle/>
+                    <a:p>
+                      <a:pPr algn="l"/>
+                      <a:r>
+                        <a:rPr sz="950" b="1">
+                          <a:solidFill>
+                            <a:srgbClr val="FFFFFF"/>
+                          </a:solidFill>
+                          <a:latin typeface="Arial"/>
+                        </a:rPr>
+                        <a:t>Metric</a:t>
+                      </a:r>
+                    </a:p>
+                  </a:txBody>
+                  <a:tcPr marT="38100" marB="38100" marL="76200" marR="76200" anchor="ctr">
+                    <a:solidFill>
+                      <a:srgbClr val="0A0A0A"/>
+                    </a:solidFill>
+                  </a:tcPr>
+                </a:tc>
+                <a:tc>
+                  <a:txBody>
+                    <a:bodyPr/>
+                    <a:lstStyle/>
+                    <a:p>
+                      <a:pPr algn="r"/>
+                      <a:r>
+                        <a:rPr sz="950" b="1">
+                          <a:solidFill>
+                            <a:srgbClr val="FFFFFF"/>
+                          </a:solidFill>
+                          <a:latin typeface="Arial"/>
+                        </a:rPr>
+                        <a:t>Goal</a:t>
+                      </a:r>
+                    </a:p>
+                  </a:txBody>
+                  <a:tcPr marT="38100" marB="38100" marL="76200" marR="76200" anchor="ctr">
+                    <a:solidFill>
+                      <a:srgbClr val="0A0A0A"/>
+                    </a:solidFill>
+                  </a:tcPr>
+                </a:tc>
+                <a:tc>
+                  <a:txBody>
+                    <a:bodyPr/>
+                    <a:lstStyle/>
+                    <a:p>
+                      <a:pPr algn="r"/>
+                      <a:r>
+                        <a:rPr sz="950" b="1">
+                          <a:solidFill>
+                            <a:srgbClr val="FFFFFF"/>
+                          </a:solidFill>
+                          <a:latin typeface="Arial"/>
+                        </a:rPr>
+                        <a:t>Actual</a:t>
+                      </a:r>
+                    </a:p>
+                  </a:txBody>
+                  <a:tcPr marT="38100" marB="38100" marL="76200" marR="76200" anchor="ctr">
+                    <a:solidFill>
+                      <a:srgbClr val="0A0A0A"/>
+                    </a:solidFill>
+                  </a:tcPr>
+                </a:tc>
+                <a:tc>
+                  <a:txBody>
+                    <a:bodyPr/>
+                    <a:lstStyle/>
+                    <a:p>
+                      <a:pPr algn="r"/>
+                      <a:r>
+                        <a:rPr sz="950" b="1">
+                          <a:solidFill>
+                            <a:srgbClr val="FFFFFF"/>
+                          </a:solidFill>
+                          <a:latin typeface="Arial"/>
+                        </a:rPr>
+                        <a:t>% of Goal</a:t>
+                      </a:r>
+                    </a:p>
+                  </a:txBody>
+                  <a:tcPr marT="38100" marB="38100" marL="76200" marR="76200" anchor="ctr">
+                    <a:solidFill>
+                      <a:srgbClr val="0A0A0A"/>
+                    </a:solidFill>
+                  </a:tcPr>
+                </a:tc>
+              </a:tr>
+              <a:tr h="210312">
+                <a:tc>
+                  <a:txBody>
+                    <a:bodyPr/>
+                    <a:lstStyle/>
+                    <a:p>
+                      <a:pPr algn="l"/>
+                      <a:r>
+                        <a:rPr sz="950" b="1">
+                          <a:solidFill>
+                            <a:srgbClr val="0A0A0A"/>
+                          </a:solidFill>
+                          <a:latin typeface="Arial"/>
+                        </a:rPr>
+                        <a:t>Leads</a:t>
+                      </a:r>
+                    </a:p>
+                  </a:txBody>
+                  <a:tcPr marT="38100" marB="38100" marL="76200" marR="76200" anchor="ctr">
+                    <a:solidFill>
+                      <a:srgbClr val="FFFFFF"/>
+                    </a:solidFill>
+                  </a:tcPr>
+                </a:tc>
+                <a:tc>
+                  <a:txBody>
+                    <a:bodyPr/>
+                    <a:lstStyle/>
+                    <a:p>
+                      <a:pPr algn="r"/>
+                      <a:r>
+                        <a:rPr sz="950" b="0">
+                          <a:solidFill>
+                            <a:srgbClr val="0A0A0A"/>
+                          </a:solidFill>
+                          <a:latin typeface="Arial"/>
+                        </a:rPr>
+                        <a:t>3,500</a:t>
+                      </a:r>
+                    </a:p>
+                  </a:txBody>
+                  <a:tcPr marT="38100" marB="38100" marL="76200" marR="76200" anchor="ctr">
+                    <a:solidFill>
+                      <a:srgbClr val="FFFFFF"/>
+                    </a:solidFill>
+                  </a:tcPr>
+                </a:tc>
+                <a:tc>
+                  <a:txBody>
+                    <a:bodyPr/>
+                    <a:lstStyle/>
+                    <a:p>
+                      <a:pPr algn="r"/>
+                      <a:r>
+                        <a:rPr sz="950" b="0">
+                          <a:solidFill>
+                            <a:srgbClr val="0A0A0A"/>
+                          </a:solidFill>
+                          <a:latin typeface="Arial"/>
+                        </a:rPr>
+                        <a:t>3,842</a:t>
+                      </a:r>
+                    </a:p>
+                  </a:txBody>
+                  <a:tcPr marT="38100" marB="38100" marL="76200" marR="76200" anchor="ctr">
+                    <a:solidFill>
+                      <a:srgbClr val="FFFFFF"/>
+                    </a:solidFill>
+                  </a:tcPr>
+                </a:tc>
+                <a:tc>
+                  <a:txBody>
+                    <a:bodyPr/>
+                    <a:lstStyle/>
+                    <a:p>
+                      <a:pPr algn="r"/>
+                      <a:r>
+                        <a:rPr sz="950" b="0">
+                          <a:solidFill>
+                            <a:srgbClr val="0A0A0A"/>
+                          </a:solidFill>
+                          <a:latin typeface="Arial"/>
+                        </a:rPr>
+                        <a:t>110%</a:t>
+                      </a:r>
+                    </a:p>
+                  </a:txBody>
+                  <a:tcPr marT="38100" marB="38100" marL="76200" marR="76200" anchor="ctr">
+                    <a:solidFill>
+                      <a:srgbClr val="FFFFFF"/>
+                    </a:solidFill>
+                  </a:tcPr>
+                </a:tc>
+              </a:tr>
+              <a:tr h="210312">
+                <a:tc>
+                  <a:txBody>
+                    <a:bodyPr/>
+                    <a:lstStyle/>
+                    <a:p>
+                      <a:pPr algn="l"/>
+                      <a:r>
+                        <a:rPr sz="950" b="1">
+                          <a:solidFill>
+                            <a:srgbClr val="0A0A0A"/>
+                          </a:solidFill>
+                          <a:latin typeface="Arial"/>
+                        </a:rPr>
+                        <a:t>MQLs</a:t>
+                      </a:r>
+                    </a:p>
+                  </a:txBody>
+                  <a:tcPr marT="38100" marB="38100" marL="76200" marR="76200" anchor="ctr">
+                    <a:solidFill>
+                      <a:srgbClr val="F5F5F5"/>
+                    </a:solidFill>
+                  </a:tcPr>
+                </a:tc>
+                <a:tc>
+                  <a:txBody>
+                    <a:bodyPr/>
+                    <a:lstStyle/>
+                    <a:p>
+                      <a:pPr algn="r"/>
+                      <a:r>
+                        <a:rPr sz="950" b="0">
+                          <a:solidFill>
+                            <a:srgbClr val="0A0A0A"/>
+                          </a:solidFill>
+                          <a:latin typeface="Arial"/>
+                        </a:rPr>
+                        <a:t>1,000</a:t>
+                      </a:r>
+                    </a:p>
+                  </a:txBody>
+                  <a:tcPr marT="38100" marB="38100" marL="76200" marR="76200" anchor="ctr">
+                    <a:solidFill>
+                      <a:srgbClr val="F5F5F5"/>
+                    </a:solidFill>
+                  </a:tcPr>
+                </a:tc>
+                <a:tc>
+                  <a:txBody>
+                    <a:bodyPr/>
+                    <a:lstStyle/>
+                    <a:p>
+                      <a:pPr algn="r"/>
+                      <a:r>
+                        <a:rPr sz="950" b="0">
+                          <a:solidFill>
+                            <a:srgbClr val="0A0A0A"/>
+                          </a:solidFill>
+                          <a:latin typeface="Arial"/>
+                        </a:rPr>
+                        <a:t>1,120</a:t>
+                      </a:r>
+                    </a:p>
+                  </a:txBody>
+                  <a:tcPr marT="38100" marB="38100" marL="76200" marR="76200" anchor="ctr">
+                    <a:solidFill>
+                      <a:srgbClr val="F5F5F5"/>
+                    </a:solidFill>
+                  </a:tcPr>
+                </a:tc>
+                <a:tc>
+                  <a:txBody>
+                    <a:bodyPr/>
+                    <a:lstStyle/>
+                    <a:p>
+                      <a:pPr algn="r"/>
+                      <a:r>
+                        <a:rPr sz="950" b="0">
+                          <a:solidFill>
+                            <a:srgbClr val="0A0A0A"/>
+                          </a:solidFill>
+                          <a:latin typeface="Arial"/>
+                        </a:rPr>
+                        <a:t>112%</a:t>
+                      </a:r>
+                    </a:p>
+                  </a:txBody>
+                  <a:tcPr marT="38100" marB="38100" marL="76200" marR="76200" anchor="ctr">
+                    <a:solidFill>
+                      <a:srgbClr val="F5F5F5"/>
+                    </a:solidFill>
+                  </a:tcPr>
+                </a:tc>
+              </a:tr>
+              <a:tr h="210312">
+                <a:tc>
+                  <a:txBody>
+                    <a:bodyPr/>
+                    <a:lstStyle/>
+                    <a:p>
+                      <a:pPr algn="l"/>
+                      <a:r>
+                        <a:rPr sz="950" b="1">
+                          <a:solidFill>
+                            <a:srgbClr val="0A0A0A"/>
+                          </a:solidFill>
+                          <a:latin typeface="Arial"/>
+                        </a:rPr>
+                        <a:t>Opportunities</a:t>
+                      </a:r>
+                    </a:p>
+                  </a:txBody>
+                  <a:tcPr marT="38100" marB="38100" marL="76200" marR="76200" anchor="ctr">
+                    <a:solidFill>
+                      <a:srgbClr val="FFFFFF"/>
+                    </a:solidFill>
+                  </a:tcPr>
+                </a:tc>
+                <a:tc>
+                  <a:txBody>
+                    <a:bodyPr/>
+                    <a:lstStyle/>
+                    <a:p>
+                      <a:pPr algn="r"/>
+                      <a:r>
+                        <a:rPr sz="950" b="0">
+                          <a:solidFill>
+                            <a:srgbClr val="0A0A0A"/>
+                          </a:solidFill>
+                          <a:latin typeface="Arial"/>
+                        </a:rPr>
+                        <a:t>250</a:t>
+                      </a:r>
+                    </a:p>
+                  </a:txBody>
+                  <a:tcPr marT="38100" marB="38100" marL="76200" marR="76200" anchor="ctr">
+                    <a:solidFill>
+                      <a:srgbClr val="FFFFFF"/>
+                    </a:solidFill>
+                  </a:tcPr>
+                </a:tc>
+                <a:tc>
+                  <a:txBody>
+                    <a:bodyPr/>
+                    <a:lstStyle/>
+                    <a:p>
+                      <a:pPr algn="r"/>
+                      <a:r>
+                        <a:rPr sz="950" b="0">
+                          <a:solidFill>
+                            <a:srgbClr val="0A0A0A"/>
+                          </a:solidFill>
+                          <a:latin typeface="Arial"/>
+                        </a:rPr>
+                        <a:t>214</a:t>
+                      </a:r>
+                    </a:p>
+                  </a:txBody>
+                  <a:tcPr marT="38100" marB="38100" marL="76200" marR="76200" anchor="ctr">
+                    <a:solidFill>
+                      <a:srgbClr val="FFFFFF"/>
+                    </a:solidFill>
+                  </a:tcPr>
+                </a:tc>
+                <a:tc>
+                  <a:txBody>
+                    <a:bodyPr/>
+                    <a:lstStyle/>
+                    <a:p>
+                      <a:pPr algn="r"/>
+                      <a:r>
+                        <a:rPr sz="950" b="0">
+                          <a:solidFill>
+                            <a:srgbClr val="0A0A0A"/>
+                          </a:solidFill>
+                          <a:latin typeface="Arial"/>
+                        </a:rPr>
+                        <a:t>86%</a:t>
+                      </a:r>
+                    </a:p>
+                  </a:txBody>
+                  <a:tcPr marT="38100" marB="38100" marL="76200" marR="76200" anchor="ctr">
+                    <a:solidFill>
+                      <a:srgbClr val="FFFFFF"/>
+                    </a:solidFill>
+                  </a:tcPr>
+                </a:tc>
+              </a:tr>
+              <a:tr h="210312">
+                <a:tc>
+                  <a:txBody>
+                    <a:bodyPr/>
+                    <a:lstStyle/>
+                    <a:p>
+                      <a:pPr algn="l"/>
+                      <a:r>
+                        <a:rPr sz="950" b="1">
+                          <a:solidFill>
+                            <a:srgbClr val="0A0A0A"/>
+                          </a:solidFill>
+                          <a:latin typeface="Arial"/>
+                        </a:rPr>
+                        <a:t>Pipeline</a:t>
+                      </a:r>
+                    </a:p>
+                  </a:txBody>
+                  <a:tcPr marT="38100" marB="38100" marL="76200" marR="76200" anchor="ctr">
+                    <a:solidFill>
+                      <a:srgbClr val="F5F5F5"/>
+                    </a:solidFill>
+                  </a:tcPr>
+                </a:tc>
+                <a:tc>
+                  <a:txBody>
+                    <a:bodyPr/>
+                    <a:lstStyle/>
+                    <a:p>
+                      <a:pPr algn="r"/>
+                      <a:r>
+                        <a:rPr sz="950" b="0">
+                          <a:solidFill>
+                            <a:srgbClr val="0A0A0A"/>
+                          </a:solidFill>
+                          <a:latin typeface="Arial"/>
+                        </a:rPr>
+                        <a:t>$3.5M</a:t>
+                      </a:r>
+                    </a:p>
+                  </a:txBody>
+                  <a:tcPr marT="38100" marB="38100" marL="76200" marR="76200" anchor="ctr">
+                    <a:solidFill>
+                      <a:srgbClr val="F5F5F5"/>
+                    </a:solidFill>
+                  </a:tcPr>
+                </a:tc>
+                <a:tc>
+                  <a:txBody>
+                    <a:bodyPr/>
+                    <a:lstStyle/>
+                    <a:p>
+                      <a:pPr algn="r"/>
+                      <a:r>
+                        <a:rPr sz="950" b="0">
+                          <a:solidFill>
+                            <a:srgbClr val="0A0A0A"/>
+                          </a:solidFill>
+                          <a:latin typeface="Arial"/>
+                        </a:rPr>
+                        <a:t>$4.8M</a:t>
+                      </a:r>
+                    </a:p>
+                  </a:txBody>
+                  <a:tcPr marT="38100" marB="38100" marL="76200" marR="76200" anchor="ctr">
+                    <a:solidFill>
+                      <a:srgbClr val="F5F5F5"/>
+                    </a:solidFill>
+                  </a:tcPr>
+                </a:tc>
+                <a:tc>
+                  <a:txBody>
+                    <a:bodyPr/>
+                    <a:lstStyle/>
+                    <a:p>
+                      <a:pPr algn="r"/>
+                      <a:r>
+                        <a:rPr sz="950" b="0">
+                          <a:solidFill>
+                            <a:srgbClr val="0A0A0A"/>
+                          </a:solidFill>
+                          <a:latin typeface="Arial"/>
+                        </a:rPr>
+                        <a:t>137%</a:t>
+                      </a:r>
+                    </a:p>
+                  </a:txBody>
+                  <a:tcPr marT="38100" marB="38100" marL="76200" marR="76200" anchor="ctr">
+                    <a:solidFill>
+                      <a:srgbClr val="F5F5F5"/>
+                    </a:solidFill>
+                  </a:tcPr>
+                </a:tc>
+              </a:tr>
+            </a:tbl>
+          </a:graphicData>
+        </a:graphic>
+      </p:graphicFrame>
+      <p:sp>
+        <p:nvSpPr>
+          <p:cNvPr id="13" name="Rounded Rectangle 12"/>
+          <p:cNvSpPr/>
+          <p:nvPr/>
+        </p:nvSpPr>
+        <p:spPr>
+          <a:xfrm>
+            <a:off x="8732520" y="932688"/>
+            <a:ext cx="3090672" cy="1234440"/>
+          </a:xfrm>
+          <a:prstGeom prst="roundRect">
+            <a:avLst>
+              <a:gd name="adj" fmla="val 6000"/>
+            </a:avLst>
+          </a:prstGeom>
+          <a:solidFill>
+            <a:srgbClr val="F5F5F5"/>
+          </a:solidFill>
+          <a:ln>
+            <a:noFill/>
+          </a:ln>
+          <a:effectLst/>
+        </p:spPr>
+        <p:style>
+          <a:lnRef idx="1">
+            <a:schemeClr val="accent1"/>
+          </a:lnRef>
+          <a:fillRef idx="3">
+            <a:schemeClr val="accent1"/>
+          </a:fillRef>
+          <a:effectRef idx="2">
+            <a:schemeClr val="accent1"/>
+          </a:effectRef>
+          <a:fontRef idx="minor">
+            <a:schemeClr val="lt1"/>
+          </a:fontRef>
+        </p:style>
+        <p:txBody>
+          <a:bodyPr rtlCol="0" anchor="ctr"/>
+          <a:lstStyle/>
+          <a:p>
+            <a:pPr algn="ctr"/>
+          </a:p>
+        </p:txBody>
+      </p:sp>
+      <p:sp>
+        <p:nvSpPr>
+          <p:cNvPr id="14" name="TextBox 13"/>
+          <p:cNvSpPr txBox="1"/>
+          <p:nvPr/>
+        </p:nvSpPr>
+        <p:spPr>
+          <a:xfrm>
+            <a:off x="8897112" y="1042416"/>
+            <a:ext cx="2743200" cy="219456"/>
+          </a:xfrm>
+          <a:prstGeom prst="rect">
+            <a:avLst/>
+          </a:prstGeom>
+          <a:noFill/>
+        </p:spPr>
+        <p:txBody>
+          <a:bodyPr wrap="square" anchor="t" lIns="0" rIns="0" tIns="0" bIns="0">
+            <a:spAutoFit/>
+          </a:bodyPr>
+          <a:lstStyle/>
+          <a:p>
+            <a:pPr algn="l"/>
+            <a:r>
+              <a:rPr sz="950" b="1" i="0" spc="10">
+                <a:solidFill>
+                  <a:srgbClr val="706E6B"/>
+                </a:solidFill>
+                <a:latin typeface="Arial"/>
+              </a:rPr>
+              <a:t>TRENDING KEY</a:t>
+            </a:r>
+          </a:p>
+        </p:txBody>
+      </p:sp>
+      <p:sp>
+        <p:nvSpPr>
+          <p:cNvPr id="15" name="Oval 14"/>
+          <p:cNvSpPr/>
+          <p:nvPr/>
+        </p:nvSpPr>
+        <p:spPr>
+          <a:xfrm>
+            <a:off x="8897112" y="1380744"/>
+            <a:ext cx="128016" cy="128016"/>
+          </a:xfrm>
+          <a:prstGeom prst="ellipse">
+            <a:avLst/>
+          </a:prstGeom>
+          <a:solidFill>
+            <a:srgbClr val="106D00"/>
+          </a:solidFill>
+          <a:ln>
+            <a:noFill/>
+          </a:ln>
+          <a:effectLst/>
+        </p:spPr>
+        <p:style>
+          <a:lnRef idx="1">
+            <a:schemeClr val="accent1"/>
+          </a:lnRef>
+          <a:fillRef idx="3">
+            <a:schemeClr val="accent1"/>
+          </a:fillRef>
+          <a:effectRef idx="2">
+            <a:schemeClr val="accent1"/>
+          </a:effectRef>
+          <a:fontRef idx="minor">
+            <a:schemeClr val="lt1"/>
+          </a:fontRef>
+        </p:style>
+        <p:txBody>
+          <a:bodyPr rtlCol="0" anchor="ctr"/>
+          <a:lstStyle/>
+          <a:p>
+            <a:pPr algn="ctr"/>
+          </a:p>
+        </p:txBody>
+      </p:sp>
+      <p:sp>
+        <p:nvSpPr>
+          <p:cNvPr id="16" name="TextBox 15"/>
+          <p:cNvSpPr txBox="1"/>
+          <p:nvPr/>
+        </p:nvSpPr>
+        <p:spPr>
+          <a:xfrm>
+            <a:off x="9116568" y="1353312"/>
+            <a:ext cx="2560320" cy="237744"/>
+          </a:xfrm>
+          <a:prstGeom prst="rect">
+            <a:avLst/>
+          </a:prstGeom>
+          <a:noFill/>
+        </p:spPr>
+        <p:txBody>
+          <a:bodyPr wrap="square" anchor="t" lIns="0" rIns="0" tIns="0" bIns="0">
+            <a:spAutoFit/>
+          </a:bodyPr>
+          <a:lstStyle/>
+          <a:p>
+            <a:pPr algn="l"/>
+            <a:r>
+              <a:rPr sz="1050" b="0" i="0">
+                <a:solidFill>
+                  <a:srgbClr val="0A0A0A"/>
+                </a:solidFill>
+                <a:latin typeface="Arial"/>
+              </a:rPr>
+              <a:t>On Plan</a:t>
+            </a:r>
+          </a:p>
+        </p:txBody>
+      </p:sp>
+      <p:sp>
+        <p:nvSpPr>
+          <p:cNvPr id="17" name="Oval 16"/>
+          <p:cNvSpPr/>
+          <p:nvPr/>
+        </p:nvSpPr>
+        <p:spPr>
+          <a:xfrm>
+            <a:off x="8897112" y="1645920"/>
+            <a:ext cx="128016" cy="128016"/>
+          </a:xfrm>
+          <a:prstGeom prst="ellipse">
+            <a:avLst/>
+          </a:prstGeom>
+          <a:solidFill>
+            <a:srgbClr val="B57A00"/>
+          </a:solidFill>
+          <a:ln>
+            <a:noFill/>
+          </a:ln>
+          <a:effectLst/>
+        </p:spPr>
+        <p:style>
+          <a:lnRef idx="1">
+            <a:schemeClr val="accent1"/>
+          </a:lnRef>
+          <a:fillRef idx="3">
+            <a:schemeClr val="accent1"/>
+          </a:fillRef>
+          <a:effectRef idx="2">
+            <a:schemeClr val="accent1"/>
+          </a:effectRef>
+          <a:fontRef idx="minor">
+            <a:schemeClr val="lt1"/>
+          </a:fontRef>
+        </p:style>
+        <p:txBody>
+          <a:bodyPr rtlCol="0" anchor="ctr"/>
+          <a:lstStyle/>
+          <a:p>
+            <a:pPr algn="ctr"/>
+          </a:p>
+        </p:txBody>
+      </p:sp>
+      <p:sp>
+        <p:nvSpPr>
+          <p:cNvPr id="18" name="TextBox 17"/>
+          <p:cNvSpPr txBox="1"/>
+          <p:nvPr/>
+        </p:nvSpPr>
+        <p:spPr>
+          <a:xfrm>
+            <a:off x="9116568" y="1618488"/>
+            <a:ext cx="2560320" cy="237744"/>
+          </a:xfrm>
+          <a:prstGeom prst="rect">
+            <a:avLst/>
+          </a:prstGeom>
+          <a:noFill/>
+        </p:spPr>
+        <p:txBody>
+          <a:bodyPr wrap="square" anchor="t" lIns="0" rIns="0" tIns="0" bIns="0">
+            <a:spAutoFit/>
+          </a:bodyPr>
+          <a:lstStyle/>
+          <a:p>
+            <a:pPr algn="l"/>
+            <a:r>
+              <a:rPr sz="1050" b="0" i="0">
+                <a:solidFill>
+                  <a:srgbClr val="0A0A0A"/>
+                </a:solidFill>
+                <a:latin typeface="Arial"/>
+              </a:rPr>
+              <a:t>Needs Attention</a:t>
+            </a:r>
+          </a:p>
+        </p:txBody>
+      </p:sp>
+      <p:sp>
+        <p:nvSpPr>
+          <p:cNvPr id="19" name="Oval 18"/>
+          <p:cNvSpPr/>
+          <p:nvPr/>
+        </p:nvSpPr>
+        <p:spPr>
+          <a:xfrm>
+            <a:off x="8897112" y="1911095"/>
+            <a:ext cx="128016" cy="128016"/>
+          </a:xfrm>
+          <a:prstGeom prst="ellipse">
+            <a:avLst/>
+          </a:prstGeom>
+          <a:solidFill>
+            <a:srgbClr val="C23934"/>
+          </a:solidFill>
+          <a:ln>
+            <a:noFill/>
+          </a:ln>
+          <a:effectLst/>
+        </p:spPr>
+        <p:style>
+          <a:lnRef idx="1">
+            <a:schemeClr val="accent1"/>
+          </a:lnRef>
+          <a:fillRef idx="3">
+            <a:schemeClr val="accent1"/>
+          </a:fillRef>
+          <a:effectRef idx="2">
+            <a:schemeClr val="accent1"/>
+          </a:effectRef>
+          <a:fontRef idx="minor">
+            <a:schemeClr val="lt1"/>
+          </a:fontRef>
+        </p:style>
+        <p:txBody>
+          <a:bodyPr rtlCol="0" anchor="ctr"/>
+          <a:lstStyle/>
+          <a:p>
+            <a:pPr algn="ctr"/>
+          </a:p>
+        </p:txBody>
+      </p:sp>
+      <p:sp>
+        <p:nvSpPr>
+          <p:cNvPr id="20" name="TextBox 19"/>
+          <p:cNvSpPr txBox="1"/>
+          <p:nvPr/>
+        </p:nvSpPr>
+        <p:spPr>
+          <a:xfrm>
+            <a:off x="9116568" y="1883664"/>
+            <a:ext cx="2560320" cy="237744"/>
+          </a:xfrm>
+          <a:prstGeom prst="rect">
+            <a:avLst/>
+          </a:prstGeom>
+          <a:noFill/>
+        </p:spPr>
+        <p:txBody>
+          <a:bodyPr wrap="square" anchor="t" lIns="0" rIns="0" tIns="0" bIns="0">
+            <a:spAutoFit/>
+          </a:bodyPr>
+          <a:lstStyle/>
+          <a:p>
+            <a:pPr algn="l"/>
+            <a:r>
+              <a:rPr sz="1050" b="0" i="0">
+                <a:solidFill>
+                  <a:srgbClr val="0A0A0A"/>
+                </a:solidFill>
+                <a:latin typeface="Arial"/>
+              </a:rPr>
+              <a:t>Under Performing</a:t>
+            </a:r>
+          </a:p>
+        </p:txBody>
+      </p:sp>
+      <p:sp>
+        <p:nvSpPr>
+          <p:cNvPr id="21" name="Rounded Rectangle 20"/>
+          <p:cNvSpPr/>
+          <p:nvPr/>
+        </p:nvSpPr>
+        <p:spPr>
+          <a:xfrm>
+            <a:off x="365760" y="2331720"/>
+            <a:ext cx="3710330" cy="3977639"/>
+          </a:xfrm>
+          <a:prstGeom prst="roundRect">
+            <a:avLst>
+              <a:gd name="adj" fmla="val 4000"/>
+            </a:avLst>
+          </a:prstGeom>
+          <a:solidFill>
+            <a:srgbClr val="F5F5F5"/>
+          </a:solidFill>
+          <a:ln>
+            <a:noFill/>
+          </a:ln>
+          <a:effectLst/>
+        </p:spPr>
+        <p:style>
+          <a:lnRef idx="1">
+            <a:schemeClr val="accent1"/>
+          </a:lnRef>
+          <a:fillRef idx="3">
+            <a:schemeClr val="accent1"/>
+          </a:fillRef>
+          <a:effectRef idx="2">
+            <a:schemeClr val="accent1"/>
+          </a:effectRef>
+          <a:fontRef idx="minor">
+            <a:schemeClr val="lt1"/>
+          </a:fontRef>
+        </p:style>
+        <p:txBody>
+          <a:bodyPr rtlCol="0" anchor="ctr"/>
+          <a:lstStyle/>
+          <a:p>
+            <a:pPr algn="ctr"/>
+          </a:p>
+        </p:txBody>
+      </p:sp>
+      <p:sp>
+        <p:nvSpPr>
+          <p:cNvPr id="22" name="Rectangle 21"/>
+          <p:cNvSpPr/>
+          <p:nvPr/>
+        </p:nvSpPr>
+        <p:spPr>
+          <a:xfrm>
+            <a:off x="365760" y="2331720"/>
+            <a:ext cx="3710330" cy="384048"/>
+          </a:xfrm>
+          <a:prstGeom prst="rect">
+            <a:avLst/>
+          </a:prstGeom>
+          <a:solidFill>
+            <a:srgbClr val="006BFF"/>
+          </a:solidFill>
+          <a:ln>
+            <a:noFill/>
+          </a:ln>
+          <a:effectLst/>
+        </p:spPr>
+        <p:style>
+          <a:lnRef idx="1">
+            <a:schemeClr val="accent1"/>
+          </a:lnRef>
+          <a:fillRef idx="3">
+            <a:schemeClr val="accent1"/>
+          </a:fillRef>
+          <a:effectRef idx="2">
+            <a:schemeClr val="accent1"/>
+          </a:effectRef>
+          <a:fontRef idx="minor">
+            <a:schemeClr val="lt1"/>
+          </a:fontRef>
+        </p:style>
+        <p:txBody>
+          <a:bodyPr rtlCol="0" anchor="ctr"/>
+          <a:lstStyle/>
+          <a:p>
+            <a:pPr algn="ctr"/>
+          </a:p>
+        </p:txBody>
+      </p:sp>
+      <p:sp>
+        <p:nvSpPr>
+          <p:cNvPr id="23" name="TextBox 22"/>
+          <p:cNvSpPr txBox="1"/>
+          <p:nvPr/>
+        </p:nvSpPr>
+        <p:spPr>
+          <a:xfrm>
+            <a:off x="512064" y="2331720"/>
+            <a:ext cx="3417722" cy="384048"/>
+          </a:xfrm>
+          <a:prstGeom prst="rect">
+            <a:avLst/>
+          </a:prstGeom>
+          <a:noFill/>
+        </p:spPr>
+        <p:txBody>
+          <a:bodyPr wrap="square" anchor="ctr" lIns="0" rIns="0" tIns="0" bIns="0">
+            <a:spAutoFit/>
+          </a:bodyPr>
+          <a:lstStyle/>
+          <a:p>
+            <a:pPr algn="l"/>
+            <a:r>
+              <a:rPr sz="1100" b="1" i="0" spc="15">
+                <a:solidFill>
+                  <a:srgbClr val="FFFFFF"/>
+                </a:solidFill>
+                <a:latin typeface="Arial"/>
+              </a:rPr>
+              <a:t>LEADS</a:t>
+            </a:r>
+          </a:p>
+        </p:txBody>
+      </p:sp>
+      <p:sp>
+        <p:nvSpPr>
+          <p:cNvPr id="24" name="TextBox 23"/>
+          <p:cNvSpPr txBox="1"/>
+          <p:nvPr/>
+        </p:nvSpPr>
+        <p:spPr>
+          <a:xfrm>
+            <a:off x="512064" y="2834639"/>
+            <a:ext cx="3417722" cy="274320"/>
+          </a:xfrm>
+          <a:prstGeom prst="rect">
+            <a:avLst/>
+          </a:prstGeom>
+          <a:noFill/>
+        </p:spPr>
+        <p:txBody>
+          <a:bodyPr wrap="square" anchor="t" lIns="0" rIns="0" tIns="0" bIns="0">
+            <a:spAutoFit/>
+          </a:bodyPr>
+          <a:lstStyle/>
+          <a:p>
+            <a:pPr algn="l"/>
+            <a:r>
+              <a:rPr sz="1150" b="1" i="0">
+                <a:solidFill>
+                  <a:srgbClr val="0A0A0A"/>
+                </a:solidFill>
+                <a:latin typeface="Arial"/>
+              </a:rPr>
+              <a:t>Total Leads: 3,842</a:t>
+            </a:r>
+          </a:p>
+        </p:txBody>
+      </p:sp>
+      <p:sp>
+        <p:nvSpPr>
+          <p:cNvPr id="25" name="TextBox 24"/>
+          <p:cNvSpPr txBox="1"/>
+          <p:nvPr/>
+        </p:nvSpPr>
+        <p:spPr>
+          <a:xfrm>
+            <a:off x="512064" y="3090672"/>
+            <a:ext cx="3417722" cy="237744"/>
+          </a:xfrm>
+          <a:prstGeom prst="rect">
+            <a:avLst/>
+          </a:prstGeom>
+          <a:noFill/>
+        </p:spPr>
+        <p:txBody>
+          <a:bodyPr wrap="square" anchor="t" lIns="0" rIns="0" tIns="0" bIns="0">
+            <a:spAutoFit/>
+          </a:bodyPr>
+          <a:lstStyle/>
+          <a:p>
+            <a:pPr algn="l"/>
+            <a:r>
+              <a:rPr sz="1000" b="0" i="0">
+                <a:solidFill>
+                  <a:srgbClr val="706E6B"/>
+                </a:solidFill>
+                <a:latin typeface="Arial"/>
+              </a:rPr>
+              <a:t>Avg Weekly Growth: +9.1%</a:t>
+            </a:r>
+          </a:p>
+        </p:txBody>
+      </p:sp>
+      <p:graphicFrame>
+        <p:nvGraphicFramePr>
+          <p:cNvPr id="26" name="Chart 25"/>
+          <p:cNvGraphicFramePr>
+            <a:graphicFrameLocks noGrp="1"/>
+          </p:cNvGraphicFramePr>
+          <p:nvPr/>
+        </p:nvGraphicFramePr>
+        <p:xfrm>
+          <a:off x="457200" y="3429000"/>
+          <a:ext cx="3527450" cy="1965960"/>
+        </p:xfrm>
+        <a:graphic>
+          <a:graphicData uri="http://schemas.openxmlformats.org/drawingml/2006/chart">
+            <c:chart xmlns:c="http://schemas.openxmlformats.org/drawingml/2006/chart" r:id="rId2"/>
+          </a:graphicData>
+        </a:graphic>
+      </p:graphicFrame>
+      <p:sp>
+        <p:nvSpPr>
+          <p:cNvPr id="27" name="TextBox 26"/>
+          <p:cNvSpPr txBox="1"/>
+          <p:nvPr/>
+        </p:nvSpPr>
+        <p:spPr>
+          <a:xfrm>
+            <a:off x="512064" y="5532120"/>
+            <a:ext cx="3417722" cy="219456"/>
+          </a:xfrm>
+          <a:prstGeom prst="rect">
+            <a:avLst/>
+          </a:prstGeom>
+          <a:noFill/>
+        </p:spPr>
+        <p:txBody>
+          <a:bodyPr wrap="square" anchor="t" lIns="0" rIns="0" tIns="0" bIns="0">
+            <a:spAutoFit/>
+          </a:bodyPr>
+          <a:lstStyle/>
+          <a:p>
+            <a:pPr algn="l"/>
+            <a:r>
+              <a:rPr sz="900" b="1" i="0" spc="10">
+                <a:solidFill>
+                  <a:srgbClr val="706E6B"/>
+                </a:solidFill>
+                <a:latin typeface="Arial"/>
+              </a:rPr>
+              <a:t>TOP CHANNEL</a:t>
+            </a:r>
+          </a:p>
+        </p:txBody>
+      </p:sp>
+      <p:sp>
+        <p:nvSpPr>
+          <p:cNvPr id="28" name="TextBox 27"/>
+          <p:cNvSpPr txBox="1"/>
+          <p:nvPr/>
+        </p:nvSpPr>
+        <p:spPr>
+          <a:xfrm>
+            <a:off x="512064" y="5760720"/>
+            <a:ext cx="3417722" cy="256032"/>
+          </a:xfrm>
+          <a:prstGeom prst="rect">
+            <a:avLst/>
+          </a:prstGeom>
+          <a:noFill/>
+        </p:spPr>
+        <p:txBody>
+          <a:bodyPr wrap="square" anchor="t" lIns="0" rIns="0" tIns="0" bIns="0">
+            <a:spAutoFit/>
+          </a:bodyPr>
+          <a:lstStyle/>
+          <a:p>
+            <a:pPr algn="l"/>
+            <a:r>
+              <a:rPr sz="1050" b="0" i="0">
+                <a:solidFill>
+                  <a:srgbClr val="0A0A0A"/>
+                </a:solidFill>
+                <a:latin typeface="Arial"/>
+              </a:rPr>
+              <a:t>Paid Search — 1,040 leads</a:t>
+            </a:r>
+          </a:p>
+        </p:txBody>
+      </p:sp>
+      <p:sp>
+        <p:nvSpPr>
+          <p:cNvPr id="29" name="Rounded Rectangle 28"/>
+          <p:cNvSpPr/>
+          <p:nvPr/>
+        </p:nvSpPr>
+        <p:spPr>
+          <a:xfrm>
+            <a:off x="4240682" y="2331720"/>
+            <a:ext cx="3710330" cy="3977639"/>
+          </a:xfrm>
+          <a:prstGeom prst="roundRect">
+            <a:avLst>
+              <a:gd name="adj" fmla="val 4000"/>
+            </a:avLst>
+          </a:prstGeom>
+          <a:solidFill>
+            <a:srgbClr val="F5F5F5"/>
+          </a:solidFill>
+          <a:ln>
+            <a:noFill/>
+          </a:ln>
+          <a:effectLst/>
+        </p:spPr>
+        <p:style>
+          <a:lnRef idx="1">
+            <a:schemeClr val="accent1"/>
+          </a:lnRef>
+          <a:fillRef idx="3">
+            <a:schemeClr val="accent1"/>
+          </a:fillRef>
+          <a:effectRef idx="2">
+            <a:schemeClr val="accent1"/>
+          </a:effectRef>
+          <a:fontRef idx="minor">
+            <a:schemeClr val="lt1"/>
+          </a:fontRef>
+        </p:style>
+        <p:txBody>
+          <a:bodyPr rtlCol="0" anchor="ctr"/>
+          <a:lstStyle/>
+          <a:p>
+            <a:pPr algn="ctr"/>
+          </a:p>
+        </p:txBody>
+      </p:sp>
+      <p:sp>
+        <p:nvSpPr>
+          <p:cNvPr id="30" name="Rectangle 29"/>
+          <p:cNvSpPr/>
+          <p:nvPr/>
+        </p:nvSpPr>
+        <p:spPr>
+          <a:xfrm>
+            <a:off x="4240682" y="2331720"/>
+            <a:ext cx="3710330" cy="384048"/>
+          </a:xfrm>
+          <a:prstGeom prst="rect">
+            <a:avLst/>
+          </a:prstGeom>
+          <a:solidFill>
+            <a:srgbClr val="009D00"/>
+          </a:solidFill>
+          <a:ln>
+            <a:noFill/>
+          </a:ln>
+          <a:effectLst/>
+        </p:spPr>
+        <p:style>
+          <a:lnRef idx="1">
+            <a:schemeClr val="accent1"/>
+          </a:lnRef>
+          <a:fillRef idx="3">
+            <a:schemeClr val="accent1"/>
+          </a:fillRef>
+          <a:effectRef idx="2">
+            <a:schemeClr val="accent1"/>
+          </a:effectRef>
+          <a:fontRef idx="minor">
+            <a:schemeClr val="lt1"/>
+          </a:fontRef>
+        </p:style>
+        <p:txBody>
+          <a:bodyPr rtlCol="0" anchor="ctr"/>
+          <a:lstStyle/>
+          <a:p>
+            <a:pPr algn="ctr"/>
+          </a:p>
+        </p:txBody>
+      </p:sp>
+      <p:sp>
+        <p:nvSpPr>
+          <p:cNvPr id="31" name="TextBox 30"/>
+          <p:cNvSpPr txBox="1"/>
+          <p:nvPr/>
+        </p:nvSpPr>
+        <p:spPr>
+          <a:xfrm>
+            <a:off x="4386986" y="2331720"/>
+            <a:ext cx="3417722" cy="384048"/>
+          </a:xfrm>
+          <a:prstGeom prst="rect">
+            <a:avLst/>
+          </a:prstGeom>
+          <a:noFill/>
+        </p:spPr>
+        <p:txBody>
+          <a:bodyPr wrap="square" anchor="ctr" lIns="0" rIns="0" tIns="0" bIns="0">
+            <a:spAutoFit/>
+          </a:bodyPr>
+          <a:lstStyle/>
+          <a:p>
+            <a:pPr algn="l"/>
+            <a:r>
+              <a:rPr sz="1100" b="1" i="0" spc="15">
+                <a:solidFill>
+                  <a:srgbClr val="FFFFFF"/>
+                </a:solidFill>
+                <a:latin typeface="Arial"/>
+              </a:rPr>
+              <a:t>OPPORTUNITY PIPELINE</a:t>
+            </a:r>
+          </a:p>
+        </p:txBody>
+      </p:sp>
+      <p:sp>
+        <p:nvSpPr>
+          <p:cNvPr id="32" name="TextBox 31"/>
+          <p:cNvSpPr txBox="1"/>
+          <p:nvPr/>
+        </p:nvSpPr>
+        <p:spPr>
+          <a:xfrm>
+            <a:off x="4386986" y="2834639"/>
+            <a:ext cx="3417722" cy="274320"/>
+          </a:xfrm>
+          <a:prstGeom prst="rect">
+            <a:avLst/>
+          </a:prstGeom>
+          <a:noFill/>
+        </p:spPr>
+        <p:txBody>
+          <a:bodyPr wrap="square" anchor="t" lIns="0" rIns="0" tIns="0" bIns="0">
+            <a:spAutoFit/>
+          </a:bodyPr>
+          <a:lstStyle/>
+          <a:p>
+            <a:pPr algn="l"/>
+            <a:r>
+              <a:rPr sz="1150" b="1" i="0">
+                <a:solidFill>
+                  <a:srgbClr val="0A0A0A"/>
+                </a:solidFill>
+                <a:latin typeface="Arial"/>
+              </a:rPr>
+              <a:t>YTD/QTD Pipeline: $4.8M</a:t>
+            </a:r>
+          </a:p>
+        </p:txBody>
+      </p:sp>
+      <p:sp>
+        <p:nvSpPr>
+          <p:cNvPr id="33" name="TextBox 32"/>
+          <p:cNvSpPr txBox="1"/>
+          <p:nvPr/>
+        </p:nvSpPr>
+        <p:spPr>
+          <a:xfrm>
+            <a:off x="4386986" y="3090672"/>
+            <a:ext cx="3417722" cy="237744"/>
+          </a:xfrm>
+          <a:prstGeom prst="rect">
+            <a:avLst/>
+          </a:prstGeom>
+          <a:noFill/>
+        </p:spPr>
+        <p:txBody>
+          <a:bodyPr wrap="square" anchor="t" lIns="0" rIns="0" tIns="0" bIns="0">
+            <a:spAutoFit/>
+          </a:bodyPr>
+          <a:lstStyle/>
+          <a:p>
+            <a:pPr algn="l"/>
+            <a:r>
+              <a:rPr sz="1000" b="0" i="0">
+                <a:solidFill>
+                  <a:srgbClr val="706E6B"/>
+                </a:solidFill>
+                <a:latin typeface="Arial"/>
+              </a:rPr>
+              <a:t>Avg Sales Cycle: 46 days</a:t>
+            </a:r>
+          </a:p>
+        </p:txBody>
+      </p:sp>
+      <p:graphicFrame>
+        <p:nvGraphicFramePr>
+          <p:cNvPr id="34" name="Chart 33"/>
+          <p:cNvGraphicFramePr>
+            <a:graphicFrameLocks noGrp="1"/>
+          </p:cNvGraphicFramePr>
+          <p:nvPr/>
+        </p:nvGraphicFramePr>
+        <p:xfrm>
+          <a:off x="4332122" y="3429000"/>
+          <a:ext cx="3527450" cy="1965960"/>
+        </p:xfrm>
+        <a:graphic>
+          <a:graphicData uri="http://schemas.openxmlformats.org/drawingml/2006/chart">
+            <c:chart xmlns:c="http://schemas.openxmlformats.org/drawingml/2006/chart" r:id="rId3"/>
+          </a:graphicData>
+        </a:graphic>
+      </p:graphicFrame>
+      <p:sp>
+        <p:nvSpPr>
+          <p:cNvPr id="35" name="TextBox 34"/>
+          <p:cNvSpPr txBox="1"/>
+          <p:nvPr/>
+        </p:nvSpPr>
+        <p:spPr>
+          <a:xfrm>
+            <a:off x="4386986" y="5532120"/>
+            <a:ext cx="3417722" cy="219456"/>
+          </a:xfrm>
+          <a:prstGeom prst="rect">
+            <a:avLst/>
+          </a:prstGeom>
+          <a:noFill/>
+        </p:spPr>
+        <p:txBody>
+          <a:bodyPr wrap="square" anchor="t" lIns="0" rIns="0" tIns="0" bIns="0">
+            <a:spAutoFit/>
+          </a:bodyPr>
+          <a:lstStyle/>
+          <a:p>
+            <a:pPr algn="l"/>
+            <a:r>
+              <a:rPr sz="900" b="1" i="0" spc="10">
+                <a:solidFill>
+                  <a:srgbClr val="706E6B"/>
+                </a:solidFill>
+                <a:latin typeface="Arial"/>
+              </a:rPr>
+              <a:t>CLOSED WON / LOST</a:t>
+            </a:r>
+          </a:p>
+        </p:txBody>
+      </p:sp>
+      <p:sp>
+        <p:nvSpPr>
+          <p:cNvPr id="36" name="TextBox 35"/>
+          <p:cNvSpPr txBox="1"/>
+          <p:nvPr/>
+        </p:nvSpPr>
+        <p:spPr>
+          <a:xfrm>
+            <a:off x="4386986" y="5760720"/>
+            <a:ext cx="3417722" cy="256032"/>
+          </a:xfrm>
+          <a:prstGeom prst="rect">
+            <a:avLst/>
+          </a:prstGeom>
+          <a:noFill/>
+        </p:spPr>
+        <p:txBody>
+          <a:bodyPr wrap="square" anchor="t" lIns="0" rIns="0" tIns="0" bIns="0">
+            <a:spAutoFit/>
+          </a:bodyPr>
+          <a:lstStyle/>
+          <a:p>
+            <a:pPr algn="l"/>
+            <a:r>
+              <a:rPr sz="1050" b="0" i="0">
+                <a:solidFill>
+                  <a:srgbClr val="0A0A0A"/>
+                </a:solidFill>
+                <a:latin typeface="Arial"/>
+              </a:rPr>
+              <a:t>38 Won  /  14 Lost  (73% win rate)</a:t>
+            </a:r>
+          </a:p>
+        </p:txBody>
+      </p:sp>
+      <p:sp>
+        <p:nvSpPr>
+          <p:cNvPr id="37" name="Rounded Rectangle 36"/>
+          <p:cNvSpPr/>
+          <p:nvPr/>
+        </p:nvSpPr>
+        <p:spPr>
+          <a:xfrm>
+            <a:off x="8115604" y="2331720"/>
+            <a:ext cx="3710330" cy="3977639"/>
+          </a:xfrm>
+          <a:prstGeom prst="roundRect">
+            <a:avLst>
+              <a:gd name="adj" fmla="val 4000"/>
+            </a:avLst>
+          </a:prstGeom>
+          <a:solidFill>
+            <a:srgbClr val="F5F5F5"/>
+          </a:solidFill>
+          <a:ln>
+            <a:noFill/>
+          </a:ln>
+          <a:effectLst/>
+        </p:spPr>
+        <p:style>
+          <a:lnRef idx="1">
+            <a:schemeClr val="accent1"/>
+          </a:lnRef>
+          <a:fillRef idx="3">
+            <a:schemeClr val="accent1"/>
+          </a:fillRef>
+          <a:effectRef idx="2">
+            <a:schemeClr val="accent1"/>
+          </a:effectRef>
+          <a:fontRef idx="minor">
+            <a:schemeClr val="lt1"/>
+          </a:fontRef>
+        </p:style>
+        <p:txBody>
+          <a:bodyPr rtlCol="0" anchor="ctr"/>
+          <a:lstStyle/>
+          <a:p>
+            <a:pPr algn="ctr"/>
+          </a:p>
+        </p:txBody>
+      </p:sp>
+      <p:sp>
+        <p:nvSpPr>
+          <p:cNvPr id="38" name="Rectangle 37"/>
+          <p:cNvSpPr/>
+          <p:nvPr/>
+        </p:nvSpPr>
+        <p:spPr>
+          <a:xfrm>
+            <a:off x="8115604" y="2331720"/>
+            <a:ext cx="3710330" cy="384048"/>
+          </a:xfrm>
+          <a:prstGeom prst="rect">
+            <a:avLst/>
+          </a:prstGeom>
+          <a:solidFill>
+            <a:srgbClr val="8D00FF"/>
+          </a:solidFill>
+          <a:ln>
+            <a:noFill/>
+          </a:ln>
+          <a:effectLst/>
+        </p:spPr>
+        <p:style>
+          <a:lnRef idx="1">
+            <a:schemeClr val="accent1"/>
+          </a:lnRef>
+          <a:fillRef idx="3">
+            <a:schemeClr val="accent1"/>
+          </a:fillRef>
+          <a:effectRef idx="2">
+            <a:schemeClr val="accent1"/>
+          </a:effectRef>
+          <a:fontRef idx="minor">
+            <a:schemeClr val="lt1"/>
+          </a:fontRef>
+        </p:style>
+        <p:txBody>
+          <a:bodyPr rtlCol="0" anchor="ctr"/>
+          <a:lstStyle/>
+          <a:p>
+            <a:pPr algn="ctr"/>
+          </a:p>
+        </p:txBody>
+      </p:sp>
+      <p:sp>
+        <p:nvSpPr>
+          <p:cNvPr id="39" name="TextBox 38"/>
+          <p:cNvSpPr txBox="1"/>
+          <p:nvPr/>
+        </p:nvSpPr>
+        <p:spPr>
+          <a:xfrm>
+            <a:off x="8261908" y="2331720"/>
+            <a:ext cx="3417722" cy="384048"/>
+          </a:xfrm>
+          <a:prstGeom prst="rect">
+            <a:avLst/>
+          </a:prstGeom>
+          <a:noFill/>
+        </p:spPr>
+        <p:txBody>
+          <a:bodyPr wrap="square" anchor="ctr" lIns="0" rIns="0" tIns="0" bIns="0">
+            <a:spAutoFit/>
+          </a:bodyPr>
+          <a:lstStyle/>
+          <a:p>
+            <a:pPr algn="l"/>
+            <a:r>
+              <a:rPr sz="1100" b="1" i="0" spc="15">
+                <a:solidFill>
+                  <a:srgbClr val="FFFFFF"/>
+                </a:solidFill>
+                <a:latin typeface="Arial"/>
+              </a:rPr>
+              <a:t>CONVERSION TRENDS</a:t>
+            </a:r>
+          </a:p>
+        </p:txBody>
+      </p:sp>
+      <p:sp>
+        <p:nvSpPr>
+          <p:cNvPr id="40" name="TextBox 39"/>
+          <p:cNvSpPr txBox="1"/>
+          <p:nvPr/>
+        </p:nvSpPr>
+        <p:spPr>
+          <a:xfrm>
+            <a:off x="8261908" y="2834639"/>
+            <a:ext cx="1554480" cy="237744"/>
+          </a:xfrm>
+          <a:prstGeom prst="rect">
+            <a:avLst/>
+          </a:prstGeom>
+          <a:noFill/>
+        </p:spPr>
+        <p:txBody>
+          <a:bodyPr wrap="square" anchor="t" lIns="0" rIns="0" tIns="0" bIns="0">
+            <a:spAutoFit/>
+          </a:bodyPr>
+          <a:lstStyle/>
+          <a:p>
+            <a:pPr algn="l"/>
+            <a:r>
+              <a:rPr sz="950" b="0" i="0">
+                <a:solidFill>
+                  <a:srgbClr val="706E6B"/>
+                </a:solidFill>
+                <a:latin typeface="Arial"/>
+              </a:rPr>
+              <a:t>MQLs MoM</a:t>
+            </a:r>
+          </a:p>
+        </p:txBody>
+      </p:sp>
+      <p:sp>
+        <p:nvSpPr>
+          <p:cNvPr id="41" name="TextBox 40"/>
+          <p:cNvSpPr txBox="1"/>
+          <p:nvPr/>
+        </p:nvSpPr>
+        <p:spPr>
+          <a:xfrm>
+            <a:off x="8261908" y="3054096"/>
+            <a:ext cx="1554480" cy="292608"/>
+          </a:xfrm>
+          <a:prstGeom prst="rect">
+            <a:avLst/>
+          </a:prstGeom>
+          <a:noFill/>
+        </p:spPr>
+        <p:txBody>
+          <a:bodyPr wrap="square" anchor="t" lIns="0" rIns="0" tIns="0" bIns="0">
+            <a:spAutoFit/>
+          </a:bodyPr>
+          <a:lstStyle/>
+          <a:p>
+            <a:pPr algn="l"/>
+            <a:r>
+              <a:rPr sz="1500" b="1" i="0">
+                <a:solidFill>
+                  <a:srgbClr val="106D00"/>
+                </a:solidFill>
+                <a:latin typeface="Arial"/>
+              </a:rPr>
+              <a:t>+9.7%</a:t>
+            </a:r>
+          </a:p>
+        </p:txBody>
+      </p:sp>
+      <p:sp>
+        <p:nvSpPr>
+          <p:cNvPr id="42" name="Rectangle 41"/>
+          <p:cNvSpPr/>
+          <p:nvPr/>
+        </p:nvSpPr>
+        <p:spPr>
+          <a:xfrm>
+            <a:off x="9970770" y="2852927"/>
+            <a:ext cx="10972" cy="457200"/>
+          </a:xfrm>
+          <a:prstGeom prst="rect">
+            <a:avLst/>
+          </a:prstGeom>
+          <a:solidFill>
+            <a:srgbClr val="E0E0E0"/>
+          </a:solidFill>
+          <a:ln>
+            <a:noFill/>
+          </a:ln>
+          <a:effectLst/>
+        </p:spPr>
+        <p:style>
+          <a:lnRef idx="1">
+            <a:schemeClr val="accent1"/>
+          </a:lnRef>
+          <a:fillRef idx="3">
+            <a:schemeClr val="accent1"/>
+          </a:fillRef>
+          <a:effectRef idx="2">
+            <a:schemeClr val="accent1"/>
+          </a:effectRef>
+          <a:fontRef idx="minor">
+            <a:schemeClr val="lt1"/>
+          </a:fontRef>
+        </p:style>
+        <p:txBody>
+          <a:bodyPr rtlCol="0" anchor="ctr"/>
+          <a:lstStyle/>
+          <a:p>
+            <a:pPr algn="ctr"/>
+          </a:p>
+        </p:txBody>
+      </p:sp>
+      <p:sp>
+        <p:nvSpPr>
+          <p:cNvPr id="43" name="TextBox 42"/>
+          <p:cNvSpPr txBox="1"/>
+          <p:nvPr/>
+        </p:nvSpPr>
+        <p:spPr>
+          <a:xfrm>
+            <a:off x="10117074" y="2834639"/>
+            <a:ext cx="1554480" cy="237744"/>
+          </a:xfrm>
+          <a:prstGeom prst="rect">
+            <a:avLst/>
+          </a:prstGeom>
+          <a:noFill/>
+        </p:spPr>
+        <p:txBody>
+          <a:bodyPr wrap="square" anchor="t" lIns="0" rIns="0" tIns="0" bIns="0">
+            <a:spAutoFit/>
+          </a:bodyPr>
+          <a:lstStyle/>
+          <a:p>
+            <a:pPr algn="l"/>
+            <a:r>
+              <a:rPr sz="950" b="0" i="0">
+                <a:solidFill>
+                  <a:srgbClr val="706E6B"/>
+                </a:solidFill>
+                <a:latin typeface="Arial"/>
+              </a:rPr>
+              <a:t>Opps MoM</a:t>
+            </a:r>
+          </a:p>
+        </p:txBody>
+      </p:sp>
+      <p:sp>
+        <p:nvSpPr>
+          <p:cNvPr id="44" name="TextBox 43"/>
+          <p:cNvSpPr txBox="1"/>
+          <p:nvPr/>
+        </p:nvSpPr>
+        <p:spPr>
+          <a:xfrm>
+            <a:off x="10117074" y="3054096"/>
+            <a:ext cx="1554480" cy="292608"/>
+          </a:xfrm>
+          <a:prstGeom prst="rect">
+            <a:avLst/>
+          </a:prstGeom>
+          <a:noFill/>
+        </p:spPr>
+        <p:txBody>
+          <a:bodyPr wrap="square" anchor="t" lIns="0" rIns="0" tIns="0" bIns="0">
+            <a:spAutoFit/>
+          </a:bodyPr>
+          <a:lstStyle/>
+          <a:p>
+            <a:pPr algn="l"/>
+            <a:r>
+              <a:rPr sz="1500" b="1" i="0">
+                <a:solidFill>
+                  <a:srgbClr val="B57A00"/>
+                </a:solidFill>
+                <a:latin typeface="Arial"/>
+              </a:rPr>
+              <a:t>-3.1%</a:t>
+            </a:r>
+          </a:p>
+        </p:txBody>
+      </p:sp>
+      <p:sp>
+        <p:nvSpPr>
+          <p:cNvPr id="45" name="TextBox 44"/>
+          <p:cNvSpPr txBox="1"/>
+          <p:nvPr/>
+        </p:nvSpPr>
+        <p:spPr>
+          <a:xfrm>
+            <a:off x="8261908" y="3474720"/>
+            <a:ext cx="3417722" cy="219456"/>
+          </a:xfrm>
+          <a:prstGeom prst="rect">
+            <a:avLst/>
+          </a:prstGeom>
+          <a:noFill/>
+        </p:spPr>
+        <p:txBody>
+          <a:bodyPr wrap="square" anchor="t" lIns="0" rIns="0" tIns="0" bIns="0">
+            <a:spAutoFit/>
+          </a:bodyPr>
+          <a:lstStyle/>
+          <a:p>
+            <a:pPr algn="l"/>
+            <a:r>
+              <a:rPr sz="950" b="1" i="0" spc="10">
+                <a:solidFill>
+                  <a:srgbClr val="706E6B"/>
+                </a:solidFill>
+                <a:latin typeface="Arial"/>
+              </a:rPr>
+              <a:t>KEY OPPORTUNITIES</a:t>
+            </a:r>
+          </a:p>
+        </p:txBody>
+      </p:sp>
+      <p:sp>
+        <p:nvSpPr>
+          <p:cNvPr id="46" name="Rounded Rectangle 45"/>
+          <p:cNvSpPr/>
+          <p:nvPr/>
+        </p:nvSpPr>
+        <p:spPr>
+          <a:xfrm>
+            <a:off x="8261908" y="3721608"/>
+            <a:ext cx="3417722" cy="402336"/>
+          </a:xfrm>
+          <a:prstGeom prst="roundRect">
+            <a:avLst>
+              <a:gd name="adj" fmla="val 15000"/>
+            </a:avLst>
+          </a:prstGeom>
+          <a:solidFill>
+            <a:srgbClr val="FFFFFF"/>
+          </a:solidFill>
+          <a:ln>
+            <a:noFill/>
+          </a:ln>
+          <a:effectLst/>
+        </p:spPr>
+        <p:style>
+          <a:lnRef idx="1">
+            <a:schemeClr val="accent1"/>
+          </a:lnRef>
+          <a:fillRef idx="3">
+            <a:schemeClr val="accent1"/>
+          </a:fillRef>
+          <a:effectRef idx="2">
+            <a:schemeClr val="accent1"/>
+          </a:effectRef>
+          <a:fontRef idx="minor">
+            <a:schemeClr val="lt1"/>
+          </a:fontRef>
+        </p:style>
+        <p:txBody>
+          <a:bodyPr rtlCol="0" anchor="ctr"/>
+          <a:lstStyle/>
+          <a:p>
+            <a:pPr algn="ctr"/>
+          </a:p>
+        </p:txBody>
+      </p:sp>
+      <p:sp>
+        <p:nvSpPr>
+          <p:cNvPr id="47" name="TextBox 46"/>
+          <p:cNvSpPr txBox="1"/>
+          <p:nvPr/>
+        </p:nvSpPr>
+        <p:spPr>
+          <a:xfrm>
+            <a:off x="8389924" y="3803904"/>
+            <a:ext cx="2887370" cy="237744"/>
+          </a:xfrm>
+          <a:prstGeom prst="rect">
+            <a:avLst/>
+          </a:prstGeom>
+          <a:noFill/>
+        </p:spPr>
+        <p:txBody>
+          <a:bodyPr wrap="square" anchor="t" lIns="0" rIns="0" tIns="0" bIns="0">
+            <a:spAutoFit/>
+          </a:bodyPr>
+          <a:lstStyle/>
+          <a:p>
+            <a:pPr algn="l"/>
+            <a:r>
+              <a:rPr sz="1050" b="1" i="0">
+                <a:solidFill>
+                  <a:srgbClr val="0A0A0A"/>
+                </a:solidFill>
+                <a:latin typeface="Arial"/>
+              </a:rPr>
+              <a:t>Global Bank Co.</a:t>
+            </a:r>
+          </a:p>
+        </p:txBody>
+      </p:sp>
+      <p:sp>
+        <p:nvSpPr>
+          <p:cNvPr id="48" name="TextBox 47"/>
+          <p:cNvSpPr txBox="1"/>
+          <p:nvPr/>
+        </p:nvSpPr>
+        <p:spPr>
+          <a:xfrm>
+            <a:off x="10911535" y="3803904"/>
+            <a:ext cx="685800" cy="237744"/>
+          </a:xfrm>
+          <a:prstGeom prst="rect">
+            <a:avLst/>
+          </a:prstGeom>
+          <a:noFill/>
+        </p:spPr>
+        <p:txBody>
+          <a:bodyPr wrap="square" anchor="t" lIns="0" rIns="0" tIns="0" bIns="0">
+            <a:spAutoFit/>
+          </a:bodyPr>
+          <a:lstStyle/>
+          <a:p>
+            <a:pPr algn="r"/>
+            <a:r>
+              <a:rPr sz="1050" b="1" i="0">
+                <a:solidFill>
+                  <a:srgbClr val="106D00"/>
+                </a:solidFill>
+                <a:latin typeface="Arial"/>
+              </a:rPr>
+              <a:t>$340K</a:t>
+            </a:r>
+          </a:p>
+        </p:txBody>
+      </p:sp>
+      <p:sp>
+        <p:nvSpPr>
+          <p:cNvPr id="49" name="Rounded Rectangle 48"/>
+          <p:cNvSpPr/>
+          <p:nvPr/>
+        </p:nvSpPr>
+        <p:spPr>
+          <a:xfrm>
+            <a:off x="8261908" y="4197096"/>
+            <a:ext cx="3417722" cy="402336"/>
+          </a:xfrm>
+          <a:prstGeom prst="roundRect">
+            <a:avLst>
+              <a:gd name="adj" fmla="val 15000"/>
+            </a:avLst>
+          </a:prstGeom>
+          <a:solidFill>
+            <a:srgbClr val="FFFFFF"/>
+          </a:solidFill>
+          <a:ln>
+            <a:noFill/>
+          </a:ln>
+          <a:effectLst/>
+        </p:spPr>
+        <p:style>
+          <a:lnRef idx="1">
+            <a:schemeClr val="accent1"/>
+          </a:lnRef>
+          <a:fillRef idx="3">
+            <a:schemeClr val="accent1"/>
+          </a:fillRef>
+          <a:effectRef idx="2">
+            <a:schemeClr val="accent1"/>
+          </a:effectRef>
+          <a:fontRef idx="minor">
+            <a:schemeClr val="lt1"/>
+          </a:fontRef>
+        </p:style>
+        <p:txBody>
+          <a:bodyPr rtlCol="0" anchor="ctr"/>
+          <a:lstStyle/>
+          <a:p>
+            <a:pPr algn="ctr"/>
+          </a:p>
+        </p:txBody>
+      </p:sp>
+      <p:sp>
+        <p:nvSpPr>
+          <p:cNvPr id="50" name="TextBox 49"/>
+          <p:cNvSpPr txBox="1"/>
+          <p:nvPr/>
+        </p:nvSpPr>
+        <p:spPr>
+          <a:xfrm>
+            <a:off x="8389924" y="4279392"/>
+            <a:ext cx="2887370" cy="237744"/>
+          </a:xfrm>
+          <a:prstGeom prst="rect">
+            <a:avLst/>
+          </a:prstGeom>
+          <a:noFill/>
+        </p:spPr>
+        <p:txBody>
+          <a:bodyPr wrap="square" anchor="t" lIns="0" rIns="0" tIns="0" bIns="0">
+            <a:spAutoFit/>
+          </a:bodyPr>
+          <a:lstStyle/>
+          <a:p>
+            <a:pPr algn="l"/>
+            <a:r>
+              <a:rPr sz="1050" b="1" i="0">
+                <a:solidFill>
+                  <a:srgbClr val="0A0A0A"/>
+                </a:solidFill>
+                <a:latin typeface="Arial"/>
+              </a:rPr>
+              <a:t>Meridian Health</a:t>
+            </a:r>
+          </a:p>
+        </p:txBody>
+      </p:sp>
+      <p:sp>
+        <p:nvSpPr>
+          <p:cNvPr id="51" name="TextBox 50"/>
+          <p:cNvSpPr txBox="1"/>
+          <p:nvPr/>
+        </p:nvSpPr>
+        <p:spPr>
+          <a:xfrm>
+            <a:off x="10911535" y="4279392"/>
+            <a:ext cx="685800" cy="237744"/>
+          </a:xfrm>
+          <a:prstGeom prst="rect">
+            <a:avLst/>
+          </a:prstGeom>
+          <a:noFill/>
+        </p:spPr>
+        <p:txBody>
+          <a:bodyPr wrap="square" anchor="t" lIns="0" rIns="0" tIns="0" bIns="0">
+            <a:spAutoFit/>
+          </a:bodyPr>
+          <a:lstStyle/>
+          <a:p>
+            <a:pPr algn="r"/>
+            <a:r>
+              <a:rPr sz="1050" b="1" i="0">
+                <a:solidFill>
+                  <a:srgbClr val="106D00"/>
+                </a:solidFill>
+                <a:latin typeface="Arial"/>
+              </a:rPr>
+              <a:t>$280K</a:t>
+            </a:r>
+          </a:p>
+        </p:txBody>
+      </p:sp>
+      <p:sp>
+        <p:nvSpPr>
+          <p:cNvPr id="52" name="Rounded Rectangle 51"/>
+          <p:cNvSpPr/>
+          <p:nvPr/>
+        </p:nvSpPr>
+        <p:spPr>
+          <a:xfrm>
+            <a:off x="8261908" y="4672583"/>
+            <a:ext cx="3417722" cy="402336"/>
+          </a:xfrm>
+          <a:prstGeom prst="roundRect">
+            <a:avLst>
+              <a:gd name="adj" fmla="val 15000"/>
+            </a:avLst>
+          </a:prstGeom>
+          <a:solidFill>
+            <a:srgbClr val="FFFFFF"/>
+          </a:solidFill>
+          <a:ln>
+            <a:noFill/>
+          </a:ln>
+          <a:effectLst/>
+        </p:spPr>
+        <p:style>
+          <a:lnRef idx="1">
+            <a:schemeClr val="accent1"/>
+          </a:lnRef>
+          <a:fillRef idx="3">
+            <a:schemeClr val="accent1"/>
+          </a:fillRef>
+          <a:effectRef idx="2">
+            <a:schemeClr val="accent1"/>
+          </a:effectRef>
+          <a:fontRef idx="minor">
+            <a:schemeClr val="lt1"/>
+          </a:fontRef>
+        </p:style>
+        <p:txBody>
+          <a:bodyPr rtlCol="0" anchor="ctr"/>
+          <a:lstStyle/>
+          <a:p>
+            <a:pPr algn="ctr"/>
+          </a:p>
+        </p:txBody>
+      </p:sp>
+      <p:sp>
+        <p:nvSpPr>
+          <p:cNvPr id="53" name="TextBox 52"/>
+          <p:cNvSpPr txBox="1"/>
+          <p:nvPr/>
+        </p:nvSpPr>
+        <p:spPr>
+          <a:xfrm>
+            <a:off x="8389924" y="4754879"/>
+            <a:ext cx="2887370" cy="237744"/>
+          </a:xfrm>
+          <a:prstGeom prst="rect">
+            <a:avLst/>
+          </a:prstGeom>
+          <a:noFill/>
+        </p:spPr>
+        <p:txBody>
+          <a:bodyPr wrap="square" anchor="t" lIns="0" rIns="0" tIns="0" bIns="0">
+            <a:spAutoFit/>
+          </a:bodyPr>
+          <a:lstStyle/>
+          <a:p>
+            <a:pPr algn="l"/>
+            <a:r>
+              <a:rPr sz="1050" b="1" i="0">
+                <a:solidFill>
+                  <a:srgbClr val="0A0A0A"/>
+                </a:solidFill>
+                <a:latin typeface="Arial"/>
+              </a:rPr>
+              <a:t>Northline Retail</a:t>
+            </a:r>
+          </a:p>
+        </p:txBody>
+      </p:sp>
+      <p:sp>
+        <p:nvSpPr>
+          <p:cNvPr id="54" name="TextBox 53"/>
+          <p:cNvSpPr txBox="1"/>
+          <p:nvPr/>
+        </p:nvSpPr>
+        <p:spPr>
+          <a:xfrm>
+            <a:off x="10911535" y="4754879"/>
+            <a:ext cx="685800" cy="237744"/>
+          </a:xfrm>
+          <a:prstGeom prst="rect">
+            <a:avLst/>
+          </a:prstGeom>
+          <a:noFill/>
+        </p:spPr>
+        <p:txBody>
+          <a:bodyPr wrap="square" anchor="t" lIns="0" rIns="0" tIns="0" bIns="0">
+            <a:spAutoFit/>
+          </a:bodyPr>
+          <a:lstStyle/>
+          <a:p>
+            <a:pPr algn="r"/>
+            <a:r>
+              <a:rPr sz="1050" b="1" i="0">
+                <a:solidFill>
+                  <a:srgbClr val="106D00"/>
+                </a:solidFill>
+                <a:latin typeface="Arial"/>
+              </a:rPr>
+              <a:t>$210K</a:t>
+            </a:r>
+          </a:p>
+        </p:txBody>
+      </p:sp>
+      <p:sp>
+        <p:nvSpPr>
+          <p:cNvPr id="55" name="TextBox 54"/>
+          <p:cNvSpPr txBox="1"/>
+          <p:nvPr/>
+        </p:nvSpPr>
+        <p:spPr>
+          <a:xfrm>
+            <a:off x="8261908" y="5202935"/>
+            <a:ext cx="3417722" cy="219456"/>
+          </a:xfrm>
+          <a:prstGeom prst="rect">
+            <a:avLst/>
+          </a:prstGeom>
+          <a:noFill/>
+        </p:spPr>
+        <p:txBody>
+          <a:bodyPr wrap="square" anchor="t" lIns="0" rIns="0" tIns="0" bIns="0">
+            <a:spAutoFit/>
+          </a:bodyPr>
+          <a:lstStyle/>
+          <a:p>
+            <a:pPr algn="l"/>
+            <a:r>
+              <a:rPr sz="950" b="1" i="0" spc="10">
+                <a:solidFill>
+                  <a:srgbClr val="706E6B"/>
+                </a:solidFill>
+                <a:latin typeface="Arial"/>
+              </a:rPr>
+              <a:t>TOP REGIONS BY PIPELINE</a:t>
+            </a:r>
+          </a:p>
+        </p:txBody>
+      </p:sp>
+      <p:sp>
+        <p:nvSpPr>
+          <p:cNvPr id="56" name="TextBox 55"/>
+          <p:cNvSpPr txBox="1"/>
+          <p:nvPr/>
+        </p:nvSpPr>
+        <p:spPr>
+          <a:xfrm>
+            <a:off x="8261908" y="5440679"/>
+            <a:ext cx="960120" cy="219456"/>
+          </a:xfrm>
+          <a:prstGeom prst="rect">
+            <a:avLst/>
+          </a:prstGeom>
+          <a:noFill/>
+        </p:spPr>
+        <p:txBody>
+          <a:bodyPr wrap="square" anchor="t" lIns="0" rIns="0" tIns="0" bIns="0">
+            <a:spAutoFit/>
+          </a:bodyPr>
+          <a:lstStyle/>
+          <a:p>
+            <a:pPr algn="l"/>
+            <a:r>
+              <a:rPr sz="900" b="0" i="0">
+                <a:solidFill>
+                  <a:srgbClr val="3E3E3C"/>
+                </a:solidFill>
+                <a:latin typeface="Arial"/>
+              </a:rPr>
+              <a:t>North America</a:t>
+            </a:r>
+          </a:p>
+        </p:txBody>
+      </p:sp>
+      <p:sp>
+        <p:nvSpPr>
+          <p:cNvPr id="57" name="Rounded Rectangle 56"/>
+          <p:cNvSpPr/>
+          <p:nvPr/>
+        </p:nvSpPr>
+        <p:spPr>
+          <a:xfrm>
+            <a:off x="9222028" y="5458967"/>
+            <a:ext cx="1972970" cy="164592"/>
+          </a:xfrm>
+          <a:prstGeom prst="roundRect">
+            <a:avLst>
+              <a:gd name="adj" fmla="val 30000"/>
+            </a:avLst>
+          </a:prstGeom>
+          <a:solidFill>
+            <a:srgbClr val="006BFF"/>
+          </a:solidFill>
+          <a:ln>
+            <a:noFill/>
+          </a:ln>
+          <a:effectLst/>
+        </p:spPr>
+        <p:style>
+          <a:lnRef idx="1">
+            <a:schemeClr val="accent1"/>
+          </a:lnRef>
+          <a:fillRef idx="3">
+            <a:schemeClr val="accent1"/>
+          </a:fillRef>
+          <a:effectRef idx="2">
+            <a:schemeClr val="accent1"/>
+          </a:effectRef>
+          <a:fontRef idx="minor">
+            <a:schemeClr val="lt1"/>
+          </a:fontRef>
+        </p:style>
+        <p:txBody>
+          <a:bodyPr rtlCol="0" anchor="ctr"/>
+          <a:lstStyle/>
+          <a:p>
+            <a:pPr algn="ctr"/>
+          </a:p>
+        </p:txBody>
+      </p:sp>
+      <p:sp>
+        <p:nvSpPr>
+          <p:cNvPr id="58" name="TextBox 57"/>
+          <p:cNvSpPr txBox="1"/>
+          <p:nvPr/>
+        </p:nvSpPr>
+        <p:spPr>
+          <a:xfrm>
+            <a:off x="11249863" y="5431536"/>
+            <a:ext cx="822960" cy="219456"/>
+          </a:xfrm>
+          <a:prstGeom prst="rect">
+            <a:avLst/>
+          </a:prstGeom>
+          <a:noFill/>
+        </p:spPr>
+        <p:txBody>
+          <a:bodyPr wrap="square" anchor="t" lIns="0" rIns="0" tIns="0" bIns="0">
+            <a:spAutoFit/>
+          </a:bodyPr>
+          <a:lstStyle/>
+          <a:p>
+            <a:pPr algn="l"/>
+            <a:r>
+              <a:rPr sz="850" b="1" i="0">
+                <a:solidFill>
+                  <a:srgbClr val="0A0A0A"/>
+                </a:solidFill>
+                <a:latin typeface="Arial"/>
+              </a:rPr>
+              <a:t>$2.16M</a:t>
+            </a:r>
+          </a:p>
+        </p:txBody>
+      </p:sp>
+      <p:sp>
+        <p:nvSpPr>
+          <p:cNvPr id="59" name="TextBox 58"/>
+          <p:cNvSpPr txBox="1"/>
+          <p:nvPr/>
+        </p:nvSpPr>
+        <p:spPr>
+          <a:xfrm>
+            <a:off x="8261908" y="5714999"/>
+            <a:ext cx="960120" cy="219456"/>
+          </a:xfrm>
+          <a:prstGeom prst="rect">
+            <a:avLst/>
+          </a:prstGeom>
+          <a:noFill/>
+        </p:spPr>
+        <p:txBody>
+          <a:bodyPr wrap="square" anchor="t" lIns="0" rIns="0" tIns="0" bIns="0">
+            <a:spAutoFit/>
+          </a:bodyPr>
+          <a:lstStyle/>
+          <a:p>
+            <a:pPr algn="l"/>
+            <a:r>
+              <a:rPr sz="900" b="0" i="0">
+                <a:solidFill>
+                  <a:srgbClr val="3E3E3C"/>
+                </a:solidFill>
+                <a:latin typeface="Arial"/>
+              </a:rPr>
+              <a:t>EMEA</a:t>
+            </a:r>
+          </a:p>
+        </p:txBody>
+      </p:sp>
+      <p:sp>
+        <p:nvSpPr>
+          <p:cNvPr id="60" name="Rounded Rectangle 59"/>
+          <p:cNvSpPr/>
+          <p:nvPr/>
+        </p:nvSpPr>
+        <p:spPr>
+          <a:xfrm>
+            <a:off x="9222028" y="5733287"/>
+            <a:ext cx="833031" cy="164592"/>
+          </a:xfrm>
+          <a:prstGeom prst="roundRect">
+            <a:avLst>
+              <a:gd name="adj" fmla="val 30000"/>
+            </a:avLst>
+          </a:prstGeom>
+          <a:solidFill>
+            <a:srgbClr val="009D00"/>
+          </a:solidFill>
+          <a:ln>
+            <a:noFill/>
+          </a:ln>
+          <a:effectLst/>
+        </p:spPr>
+        <p:style>
+          <a:lnRef idx="1">
+            <a:schemeClr val="accent1"/>
+          </a:lnRef>
+          <a:fillRef idx="3">
+            <a:schemeClr val="accent1"/>
+          </a:fillRef>
+          <a:effectRef idx="2">
+            <a:schemeClr val="accent1"/>
+          </a:effectRef>
+          <a:fontRef idx="minor">
+            <a:schemeClr val="lt1"/>
+          </a:fontRef>
+        </p:style>
+        <p:txBody>
+          <a:bodyPr rtlCol="0" anchor="ctr"/>
+          <a:lstStyle/>
+          <a:p>
+            <a:pPr algn="ctr"/>
+          </a:p>
+        </p:txBody>
+      </p:sp>
+      <p:sp>
+        <p:nvSpPr>
+          <p:cNvPr id="61" name="TextBox 60"/>
+          <p:cNvSpPr txBox="1"/>
+          <p:nvPr/>
+        </p:nvSpPr>
+        <p:spPr>
+          <a:xfrm>
+            <a:off x="10109924" y="5705855"/>
+            <a:ext cx="822960" cy="219456"/>
+          </a:xfrm>
+          <a:prstGeom prst="rect">
+            <a:avLst/>
+          </a:prstGeom>
+          <a:noFill/>
+        </p:spPr>
+        <p:txBody>
+          <a:bodyPr wrap="square" anchor="t" lIns="0" rIns="0" tIns="0" bIns="0">
+            <a:spAutoFit/>
+          </a:bodyPr>
+          <a:lstStyle/>
+          <a:p>
+            <a:pPr algn="l"/>
+            <a:r>
+              <a:rPr sz="850" b="1" i="0">
+                <a:solidFill>
+                  <a:srgbClr val="0A0A0A"/>
+                </a:solidFill>
+                <a:latin typeface="Arial"/>
+              </a:rPr>
+              <a:t>$0.91M</a:t>
+            </a:r>
+          </a:p>
+        </p:txBody>
+      </p:sp>
+      <p:sp>
+        <p:nvSpPr>
+          <p:cNvPr id="62" name="TextBox 61"/>
+          <p:cNvSpPr txBox="1"/>
+          <p:nvPr/>
+        </p:nvSpPr>
+        <p:spPr>
+          <a:xfrm>
+            <a:off x="8261908" y="5989319"/>
+            <a:ext cx="960120" cy="219456"/>
+          </a:xfrm>
+          <a:prstGeom prst="rect">
+            <a:avLst/>
+          </a:prstGeom>
+          <a:noFill/>
+        </p:spPr>
+        <p:txBody>
+          <a:bodyPr wrap="square" anchor="t" lIns="0" rIns="0" tIns="0" bIns="0">
+            <a:spAutoFit/>
+          </a:bodyPr>
+          <a:lstStyle/>
+          <a:p>
+            <a:pPr algn="l"/>
+            <a:r>
+              <a:rPr sz="900" b="0" i="0">
+                <a:solidFill>
+                  <a:srgbClr val="3E3E3C"/>
+                </a:solidFill>
+                <a:latin typeface="Arial"/>
+              </a:rPr>
+              <a:t>APAC</a:t>
+            </a:r>
+          </a:p>
+        </p:txBody>
+      </p:sp>
+      <p:sp>
+        <p:nvSpPr>
+          <p:cNvPr id="63" name="Rounded Rectangle 62"/>
+          <p:cNvSpPr/>
+          <p:nvPr/>
+        </p:nvSpPr>
+        <p:spPr>
+          <a:xfrm>
+            <a:off x="9222028" y="6007607"/>
+            <a:ext cx="526125" cy="164592"/>
+          </a:xfrm>
+          <a:prstGeom prst="roundRect">
+            <a:avLst>
+              <a:gd name="adj" fmla="val 30000"/>
+            </a:avLst>
+          </a:prstGeom>
+          <a:solidFill>
+            <a:srgbClr val="B57A00"/>
+          </a:solidFill>
+          <a:ln>
+            <a:noFill/>
+          </a:ln>
+          <a:effectLst/>
+        </p:spPr>
+        <p:style>
+          <a:lnRef idx="1">
+            <a:schemeClr val="accent1"/>
+          </a:lnRef>
+          <a:fillRef idx="3">
+            <a:schemeClr val="accent1"/>
+          </a:fillRef>
+          <a:effectRef idx="2">
+            <a:schemeClr val="accent1"/>
+          </a:effectRef>
+          <a:fontRef idx="minor">
+            <a:schemeClr val="lt1"/>
+          </a:fontRef>
+        </p:style>
+        <p:txBody>
+          <a:bodyPr rtlCol="0" anchor="ctr"/>
+          <a:lstStyle/>
+          <a:p>
+            <a:pPr algn="ctr"/>
+          </a:p>
+        </p:txBody>
+      </p:sp>
+      <p:sp>
+        <p:nvSpPr>
+          <p:cNvPr id="64" name="TextBox 63"/>
+          <p:cNvSpPr txBox="1"/>
+          <p:nvPr/>
+        </p:nvSpPr>
+        <p:spPr>
+          <a:xfrm>
+            <a:off x="9803018" y="5980175"/>
+            <a:ext cx="822960" cy="219456"/>
+          </a:xfrm>
+          <a:prstGeom prst="rect">
+            <a:avLst/>
+          </a:prstGeom>
+          <a:noFill/>
+        </p:spPr>
+        <p:txBody>
+          <a:bodyPr wrap="square" anchor="t" lIns="0" rIns="0" tIns="0" bIns="0">
+            <a:spAutoFit/>
+          </a:bodyPr>
+          <a:lstStyle/>
+          <a:p>
+            <a:pPr algn="l"/>
+            <a:r>
+              <a:rPr sz="850" b="1" i="0">
+                <a:solidFill>
+                  <a:srgbClr val="0A0A0A"/>
+                </a:solidFill>
+                <a:latin typeface="Arial"/>
+              </a:rPr>
+              <a:t>$0.58M</a:t>
+            </a:r>
+          </a:p>
+        </p:txBody>
+      </p:sp>
+      <p:sp>
+        <p:nvSpPr>
+          <p:cNvPr id="65" name="Rectangle 64"/>
+          <p:cNvSpPr/>
+          <p:nvPr/>
+        </p:nvSpPr>
+        <p:spPr>
+          <a:xfrm>
+            <a:off x="0" y="6565392"/>
+            <a:ext cx="12191695" cy="292608"/>
+          </a:xfrm>
+          <a:prstGeom prst="rect">
+            <a:avLst/>
+          </a:prstGeom>
+          <a:solidFill>
+            <a:srgbClr val="F5F5F5"/>
+          </a:solidFill>
+          <a:ln>
+            <a:noFill/>
+          </a:ln>
+          <a:effectLst/>
+        </p:spPr>
+        <p:style>
+          <a:lnRef idx="1">
+            <a:schemeClr val="accent1"/>
+          </a:lnRef>
+          <a:fillRef idx="3">
+            <a:schemeClr val="accent1"/>
+          </a:fillRef>
+          <a:effectRef idx="2">
+            <a:schemeClr val="accent1"/>
+          </a:effectRef>
+          <a:fontRef idx="minor">
+            <a:schemeClr val="lt1"/>
+          </a:fontRef>
+        </p:style>
+        <p:txBody>
+          <a:bodyPr rtlCol="0" anchor="ctr"/>
+          <a:lstStyle/>
+          <a:p>
+            <a:pPr algn="ctr"/>
+          </a:p>
+        </p:txBody>
+      </p:sp>
+      <p:sp>
+        <p:nvSpPr>
+          <p:cNvPr id="66" name="TextBox 65"/>
+          <p:cNvSpPr txBox="1"/>
+          <p:nvPr/>
+        </p:nvSpPr>
+        <p:spPr>
+          <a:xfrm>
+            <a:off x="502920" y="6583680"/>
+            <a:ext cx="8229600" cy="256032"/>
+          </a:xfrm>
+          <a:prstGeom prst="rect">
+            <a:avLst/>
+          </a:prstGeom>
+          <a:noFill/>
+        </p:spPr>
+        <p:txBody>
+          <a:bodyPr wrap="square" anchor="t" lIns="0" rIns="0" tIns="0" bIns="0">
+            <a:spAutoFit/>
+          </a:bodyPr>
+          <a:lstStyle/>
+          <a:p>
+            <a:pPr algn="l"/>
+            <a:r>
+              <a:rPr sz="800" b="0" i="1">
+                <a:solidFill>
+                  <a:srgbClr val="706E6B"/>
+                </a:solidFill>
+                <a:latin typeface="Arial"/>
+              </a:rPr>
+              <a:t>Prototype tracking slide — sample data for illustration only. Layout structure adapted from an internal template; no external branding or content included.</a:t>
+            </a:r>
+          </a:p>
+        </p:txBody>
+      </p:sp>
+      <p:sp>
+        <p:nvSpPr>
+          <p:cNvPr id="67" name="TextBox 66"/>
+          <p:cNvSpPr txBox="1"/>
+          <p:nvPr/>
+        </p:nvSpPr>
+        <p:spPr>
+          <a:xfrm>
+            <a:off x="9601200" y="6583680"/>
+            <a:ext cx="2103120" cy="256032"/>
+          </a:xfrm>
+          <a:prstGeom prst="rect">
+            <a:avLst/>
+          </a:prstGeom>
+          <a:noFill/>
+        </p:spPr>
+        <p:txBody>
+          <a:bodyPr wrap="square" anchor="t" lIns="0" rIns="0" tIns="0" bIns="0">
+            <a:spAutoFit/>
+          </a:bodyPr>
+          <a:lstStyle/>
+          <a:p>
+            <a:pPr algn="r"/>
+            <a:r>
+              <a:rPr sz="850" b="0" i="0">
+                <a:solidFill>
+                  <a:srgbClr val="706E6B"/>
+                </a:solidFill>
+                <a:latin typeface="Arial"/>
+              </a:rPr>
+              <a:t>Page 2 of 2</a:t>
             </a:r>
           </a:p>
         </p:txBody>

</xml_diff>

<commit_message>
Show top 3 channels instead of top 1 in the Leads card on the performance tracking slide
</commit_message>
<xml_diff>
--- a/Insider_Threat_Campaign_Scorecard.pptx
+++ b/Insider_Threat_Campaign_Scorecard.pptx
@@ -7653,7 +7653,7 @@
         </p:nvGraphicFramePr>
         <p:xfrm>
           <a:off x="457200" y="3429000"/>
-          <a:ext cx="3527450" cy="1965960"/>
+          <a:ext cx="3527450" cy="1828800"/>
         </p:xfrm>
         <a:graphic>
           <a:graphicData uri="http://schemas.openxmlformats.org/drawingml/2006/chart">
@@ -7669,8 +7669,8 @@
         </p:nvSpPr>
         <p:spPr>
           <a:xfrm>
-            <a:off x="512064" y="5532120"/>
-            <a:ext cx="3417722" cy="219456"/>
+            <a:off x="512064" y="5367527"/>
+            <a:ext cx="3417722" cy="201168"/>
           </a:xfrm>
           <a:prstGeom prst="rect">
             <a:avLst/>
@@ -7691,7 +7691,7 @@
                 </a:solidFill>
                 <a:latin typeface="Arial"/>
               </a:rPr>
-              <a:t>TOP CHANNEL</a:t>
+              <a:t>TOP 3 CHANNELS</a:t>
             </a:r>
           </a:p>
         </p:txBody>
@@ -7704,8 +7704,8 @@
         </p:nvSpPr>
         <p:spPr>
           <a:xfrm>
-            <a:off x="512064" y="5760720"/>
-            <a:ext cx="3417722" cy="256032"/>
+            <a:off x="512064" y="5586983"/>
+            <a:ext cx="2704490" cy="201168"/>
           </a:xfrm>
           <a:prstGeom prst="rect">
             <a:avLst/>
@@ -7720,20 +7720,195 @@
           <a:p>
             <a:pPr algn="l"/>
             <a:r>
-              <a:rPr sz="1050" b="0" i="0">
+              <a:rPr sz="950" b="0" i="0">
                 <a:solidFill>
                   <a:srgbClr val="0A0A0A"/>
                 </a:solidFill>
                 <a:latin typeface="Arial"/>
               </a:rPr>
-              <a:t>Paid Search — 1,040 leads</a:t>
-            </a:r>
-          </a:p>
-        </p:txBody>
-      </p:sp>
-      <p:sp>
-        <p:nvSpPr>
-          <p:cNvPr id="29" name="Rounded Rectangle 28"/>
+              <a:t>Paid Search</a:t>
+            </a:r>
+          </a:p>
+        </p:txBody>
+      </p:sp>
+      <p:sp>
+        <p:nvSpPr>
+          <p:cNvPr id="29" name="TextBox 28"/>
+          <p:cNvSpPr txBox="1"/>
+          <p:nvPr/>
+        </p:nvSpPr>
+        <p:spPr>
+          <a:xfrm>
+            <a:off x="3161690" y="5586983"/>
+            <a:ext cx="768096" cy="201168"/>
+          </a:xfrm>
+          <a:prstGeom prst="rect">
+            <a:avLst/>
+          </a:prstGeom>
+          <a:noFill/>
+        </p:spPr>
+        <p:txBody>
+          <a:bodyPr wrap="square" anchor="t" lIns="0" rIns="0" tIns="0" bIns="0">
+            <a:spAutoFit/>
+          </a:bodyPr>
+          <a:lstStyle/>
+          <a:p>
+            <a:pPr algn="r"/>
+            <a:r>
+              <a:rPr sz="950" b="1" i="0">
+                <a:solidFill>
+                  <a:srgbClr val="0A0A0A"/>
+                </a:solidFill>
+                <a:latin typeface="Arial"/>
+              </a:rPr>
+              <a:t>1,040</a:t>
+            </a:r>
+          </a:p>
+        </p:txBody>
+      </p:sp>
+      <p:sp>
+        <p:nvSpPr>
+          <p:cNvPr id="30" name="TextBox 29"/>
+          <p:cNvSpPr txBox="1"/>
+          <p:nvPr/>
+        </p:nvSpPr>
+        <p:spPr>
+          <a:xfrm>
+            <a:off x="512064" y="5792723"/>
+            <a:ext cx="2704490" cy="201168"/>
+          </a:xfrm>
+          <a:prstGeom prst="rect">
+            <a:avLst/>
+          </a:prstGeom>
+          <a:noFill/>
+        </p:spPr>
+        <p:txBody>
+          <a:bodyPr wrap="square" anchor="t" lIns="0" rIns="0" tIns="0" bIns="0">
+            <a:spAutoFit/>
+          </a:bodyPr>
+          <a:lstStyle/>
+          <a:p>
+            <a:pPr algn="l"/>
+            <a:r>
+              <a:rPr sz="950" b="0" i="0">
+                <a:solidFill>
+                  <a:srgbClr val="0A0A0A"/>
+                </a:solidFill>
+                <a:latin typeface="Arial"/>
+              </a:rPr>
+              <a:t>Email Nurture</a:t>
+            </a:r>
+          </a:p>
+        </p:txBody>
+      </p:sp>
+      <p:sp>
+        <p:nvSpPr>
+          <p:cNvPr id="31" name="TextBox 30"/>
+          <p:cNvSpPr txBox="1"/>
+          <p:nvPr/>
+        </p:nvSpPr>
+        <p:spPr>
+          <a:xfrm>
+            <a:off x="3161690" y="5792723"/>
+            <a:ext cx="768096" cy="201168"/>
+          </a:xfrm>
+          <a:prstGeom prst="rect">
+            <a:avLst/>
+          </a:prstGeom>
+          <a:noFill/>
+        </p:spPr>
+        <p:txBody>
+          <a:bodyPr wrap="square" anchor="t" lIns="0" rIns="0" tIns="0" bIns="0">
+            <a:spAutoFit/>
+          </a:bodyPr>
+          <a:lstStyle/>
+          <a:p>
+            <a:pPr algn="r"/>
+            <a:r>
+              <a:rPr sz="950" b="1" i="0">
+                <a:solidFill>
+                  <a:srgbClr val="0A0A0A"/>
+                </a:solidFill>
+                <a:latin typeface="Arial"/>
+              </a:rPr>
+              <a:t>980</a:t>
+            </a:r>
+          </a:p>
+        </p:txBody>
+      </p:sp>
+      <p:sp>
+        <p:nvSpPr>
+          <p:cNvPr id="32" name="TextBox 31"/>
+          <p:cNvSpPr txBox="1"/>
+          <p:nvPr/>
+        </p:nvSpPr>
+        <p:spPr>
+          <a:xfrm>
+            <a:off x="512064" y="5998463"/>
+            <a:ext cx="2704490" cy="201168"/>
+          </a:xfrm>
+          <a:prstGeom prst="rect">
+            <a:avLst/>
+          </a:prstGeom>
+          <a:noFill/>
+        </p:spPr>
+        <p:txBody>
+          <a:bodyPr wrap="square" anchor="t" lIns="0" rIns="0" tIns="0" bIns="0">
+            <a:spAutoFit/>
+          </a:bodyPr>
+          <a:lstStyle/>
+          <a:p>
+            <a:pPr algn="l"/>
+            <a:r>
+              <a:rPr sz="950" b="0" i="0">
+                <a:solidFill>
+                  <a:srgbClr val="0A0A0A"/>
+                </a:solidFill>
+                <a:latin typeface="Arial"/>
+              </a:rPr>
+              <a:t>Webinar</a:t>
+            </a:r>
+          </a:p>
+        </p:txBody>
+      </p:sp>
+      <p:sp>
+        <p:nvSpPr>
+          <p:cNvPr id="33" name="TextBox 32"/>
+          <p:cNvSpPr txBox="1"/>
+          <p:nvPr/>
+        </p:nvSpPr>
+        <p:spPr>
+          <a:xfrm>
+            <a:off x="3161690" y="5998463"/>
+            <a:ext cx="768096" cy="201168"/>
+          </a:xfrm>
+          <a:prstGeom prst="rect">
+            <a:avLst/>
+          </a:prstGeom>
+          <a:noFill/>
+        </p:spPr>
+        <p:txBody>
+          <a:bodyPr wrap="square" anchor="t" lIns="0" rIns="0" tIns="0" bIns="0">
+            <a:spAutoFit/>
+          </a:bodyPr>
+          <a:lstStyle/>
+          <a:p>
+            <a:pPr algn="r"/>
+            <a:r>
+              <a:rPr sz="950" b="1" i="0">
+                <a:solidFill>
+                  <a:srgbClr val="0A0A0A"/>
+                </a:solidFill>
+                <a:latin typeface="Arial"/>
+              </a:rPr>
+              <a:t>612</a:t>
+            </a:r>
+          </a:p>
+        </p:txBody>
+      </p:sp>
+      <p:sp>
+        <p:nvSpPr>
+          <p:cNvPr id="34" name="Rounded Rectangle 33"/>
           <p:cNvSpPr/>
           <p:nvPr/>
         </p:nvSpPr>
@@ -7779,7 +7954,7 @@
       </p:sp>
       <p:sp>
         <p:nvSpPr>
-          <p:cNvPr id="30" name="Rectangle 29"/>
+          <p:cNvPr id="35" name="Rectangle 34"/>
           <p:cNvSpPr/>
           <p:nvPr/>
         </p:nvSpPr>
@@ -7823,7 +7998,7 @@
       </p:sp>
       <p:sp>
         <p:nvSpPr>
-          <p:cNvPr id="31" name="TextBox 30"/>
+          <p:cNvPr id="36" name="TextBox 35"/>
           <p:cNvSpPr txBox="1"/>
           <p:nvPr/>
         </p:nvSpPr>
@@ -7858,7 +8033,7 @@
       </p:sp>
       <p:sp>
         <p:nvSpPr>
-          <p:cNvPr id="32" name="TextBox 31"/>
+          <p:cNvPr id="37" name="TextBox 36"/>
           <p:cNvSpPr txBox="1"/>
           <p:nvPr/>
         </p:nvSpPr>
@@ -7893,7 +8068,7 @@
       </p:sp>
       <p:sp>
         <p:nvSpPr>
-          <p:cNvPr id="33" name="TextBox 32"/>
+          <p:cNvPr id="38" name="TextBox 37"/>
           <p:cNvSpPr txBox="1"/>
           <p:nvPr/>
         </p:nvSpPr>
@@ -7928,7 +8103,7 @@
       </p:sp>
       <p:graphicFrame>
         <p:nvGraphicFramePr>
-          <p:cNvPr id="34" name="Chart 33"/>
+          <p:cNvPr id="39" name="Chart 38"/>
           <p:cNvGraphicFramePr>
             <a:graphicFrameLocks noGrp="1"/>
           </p:cNvGraphicFramePr>
@@ -7946,7 +8121,7 @@
       </p:graphicFrame>
       <p:sp>
         <p:nvSpPr>
-          <p:cNvPr id="35" name="TextBox 34"/>
+          <p:cNvPr id="40" name="TextBox 39"/>
           <p:cNvSpPr txBox="1"/>
           <p:nvPr/>
         </p:nvSpPr>
@@ -7981,7 +8156,7 @@
       </p:sp>
       <p:sp>
         <p:nvSpPr>
-          <p:cNvPr id="36" name="TextBox 35"/>
+          <p:cNvPr id="41" name="TextBox 40"/>
           <p:cNvSpPr txBox="1"/>
           <p:nvPr/>
         </p:nvSpPr>
@@ -8016,7 +8191,7 @@
       </p:sp>
       <p:sp>
         <p:nvSpPr>
-          <p:cNvPr id="37" name="Rounded Rectangle 36"/>
+          <p:cNvPr id="42" name="Rounded Rectangle 41"/>
           <p:cNvSpPr/>
           <p:nvPr/>
         </p:nvSpPr>
@@ -8062,7 +8237,7 @@
       </p:sp>
       <p:sp>
         <p:nvSpPr>
-          <p:cNvPr id="38" name="Rectangle 37"/>
+          <p:cNvPr id="43" name="Rectangle 42"/>
           <p:cNvSpPr/>
           <p:nvPr/>
         </p:nvSpPr>
@@ -8106,7 +8281,7 @@
       </p:sp>
       <p:sp>
         <p:nvSpPr>
-          <p:cNvPr id="39" name="TextBox 38"/>
+          <p:cNvPr id="44" name="TextBox 43"/>
           <p:cNvSpPr txBox="1"/>
           <p:nvPr/>
         </p:nvSpPr>
@@ -8141,7 +8316,7 @@
       </p:sp>
       <p:sp>
         <p:nvSpPr>
-          <p:cNvPr id="40" name="TextBox 39"/>
+          <p:cNvPr id="45" name="TextBox 44"/>
           <p:cNvSpPr txBox="1"/>
           <p:nvPr/>
         </p:nvSpPr>
@@ -8176,7 +8351,7 @@
       </p:sp>
       <p:sp>
         <p:nvSpPr>
-          <p:cNvPr id="41" name="TextBox 40"/>
+          <p:cNvPr id="46" name="TextBox 45"/>
           <p:cNvSpPr txBox="1"/>
           <p:nvPr/>
         </p:nvSpPr>
@@ -8211,7 +8386,7 @@
       </p:sp>
       <p:sp>
         <p:nvSpPr>
-          <p:cNvPr id="42" name="Rectangle 41"/>
+          <p:cNvPr id="47" name="Rectangle 46"/>
           <p:cNvSpPr/>
           <p:nvPr/>
         </p:nvSpPr>
@@ -8255,7 +8430,7 @@
       </p:sp>
       <p:sp>
         <p:nvSpPr>
-          <p:cNvPr id="43" name="TextBox 42"/>
+          <p:cNvPr id="48" name="TextBox 47"/>
           <p:cNvSpPr txBox="1"/>
           <p:nvPr/>
         </p:nvSpPr>
@@ -8290,7 +8465,7 @@
       </p:sp>
       <p:sp>
         <p:nvSpPr>
-          <p:cNvPr id="44" name="TextBox 43"/>
+          <p:cNvPr id="49" name="TextBox 48"/>
           <p:cNvSpPr txBox="1"/>
           <p:nvPr/>
         </p:nvSpPr>
@@ -8325,7 +8500,7 @@
       </p:sp>
       <p:sp>
         <p:nvSpPr>
-          <p:cNvPr id="45" name="TextBox 44"/>
+          <p:cNvPr id="50" name="TextBox 49"/>
           <p:cNvSpPr txBox="1"/>
           <p:nvPr/>
         </p:nvSpPr>
@@ -8360,7 +8535,7 @@
       </p:sp>
       <p:sp>
         <p:nvSpPr>
-          <p:cNvPr id="46" name="Rounded Rectangle 45"/>
+          <p:cNvPr id="51" name="Rounded Rectangle 50"/>
           <p:cNvSpPr/>
           <p:nvPr/>
         </p:nvSpPr>
@@ -8406,7 +8581,7 @@
       </p:sp>
       <p:sp>
         <p:nvSpPr>
-          <p:cNvPr id="47" name="TextBox 46"/>
+          <p:cNvPr id="52" name="TextBox 51"/>
           <p:cNvSpPr txBox="1"/>
           <p:nvPr/>
         </p:nvSpPr>
@@ -8441,7 +8616,7 @@
       </p:sp>
       <p:sp>
         <p:nvSpPr>
-          <p:cNvPr id="48" name="TextBox 47"/>
+          <p:cNvPr id="53" name="TextBox 52"/>
           <p:cNvSpPr txBox="1"/>
           <p:nvPr/>
         </p:nvSpPr>
@@ -8476,7 +8651,7 @@
       </p:sp>
       <p:sp>
         <p:nvSpPr>
-          <p:cNvPr id="49" name="Rounded Rectangle 48"/>
+          <p:cNvPr id="54" name="Rounded Rectangle 53"/>
           <p:cNvSpPr/>
           <p:nvPr/>
         </p:nvSpPr>
@@ -8522,7 +8697,7 @@
       </p:sp>
       <p:sp>
         <p:nvSpPr>
-          <p:cNvPr id="50" name="TextBox 49"/>
+          <p:cNvPr id="55" name="TextBox 54"/>
           <p:cNvSpPr txBox="1"/>
           <p:nvPr/>
         </p:nvSpPr>
@@ -8557,7 +8732,7 @@
       </p:sp>
       <p:sp>
         <p:nvSpPr>
-          <p:cNvPr id="51" name="TextBox 50"/>
+          <p:cNvPr id="56" name="TextBox 55"/>
           <p:cNvSpPr txBox="1"/>
           <p:nvPr/>
         </p:nvSpPr>
@@ -8592,7 +8767,7 @@
       </p:sp>
       <p:sp>
         <p:nvSpPr>
-          <p:cNvPr id="52" name="Rounded Rectangle 51"/>
+          <p:cNvPr id="57" name="Rounded Rectangle 56"/>
           <p:cNvSpPr/>
           <p:nvPr/>
         </p:nvSpPr>
@@ -8638,7 +8813,7 @@
       </p:sp>
       <p:sp>
         <p:nvSpPr>
-          <p:cNvPr id="53" name="TextBox 52"/>
+          <p:cNvPr id="58" name="TextBox 57"/>
           <p:cNvSpPr txBox="1"/>
           <p:nvPr/>
         </p:nvSpPr>
@@ -8673,7 +8848,7 @@
       </p:sp>
       <p:sp>
         <p:nvSpPr>
-          <p:cNvPr id="54" name="TextBox 53"/>
+          <p:cNvPr id="59" name="TextBox 58"/>
           <p:cNvSpPr txBox="1"/>
           <p:nvPr/>
         </p:nvSpPr>
@@ -8708,7 +8883,7 @@
       </p:sp>
       <p:sp>
         <p:nvSpPr>
-          <p:cNvPr id="55" name="TextBox 54"/>
+          <p:cNvPr id="60" name="TextBox 59"/>
           <p:cNvSpPr txBox="1"/>
           <p:nvPr/>
         </p:nvSpPr>
@@ -8743,7 +8918,7 @@
       </p:sp>
       <p:sp>
         <p:nvSpPr>
-          <p:cNvPr id="56" name="TextBox 55"/>
+          <p:cNvPr id="61" name="TextBox 60"/>
           <p:cNvSpPr txBox="1"/>
           <p:nvPr/>
         </p:nvSpPr>
@@ -8778,7 +8953,7 @@
       </p:sp>
       <p:sp>
         <p:nvSpPr>
-          <p:cNvPr id="57" name="Rounded Rectangle 56"/>
+          <p:cNvPr id="62" name="Rounded Rectangle 61"/>
           <p:cNvSpPr/>
           <p:nvPr/>
         </p:nvSpPr>
@@ -8824,7 +8999,7 @@
       </p:sp>
       <p:sp>
         <p:nvSpPr>
-          <p:cNvPr id="58" name="TextBox 57"/>
+          <p:cNvPr id="63" name="TextBox 62"/>
           <p:cNvSpPr txBox="1"/>
           <p:nvPr/>
         </p:nvSpPr>
@@ -8859,7 +9034,7 @@
       </p:sp>
       <p:sp>
         <p:nvSpPr>
-          <p:cNvPr id="59" name="TextBox 58"/>
+          <p:cNvPr id="64" name="TextBox 63"/>
           <p:cNvSpPr txBox="1"/>
           <p:nvPr/>
         </p:nvSpPr>
@@ -8894,7 +9069,7 @@
       </p:sp>
       <p:sp>
         <p:nvSpPr>
-          <p:cNvPr id="60" name="Rounded Rectangle 59"/>
+          <p:cNvPr id="65" name="Rounded Rectangle 64"/>
           <p:cNvSpPr/>
           <p:nvPr/>
         </p:nvSpPr>
@@ -8940,7 +9115,7 @@
       </p:sp>
       <p:sp>
         <p:nvSpPr>
-          <p:cNvPr id="61" name="TextBox 60"/>
+          <p:cNvPr id="66" name="TextBox 65"/>
           <p:cNvSpPr txBox="1"/>
           <p:nvPr/>
         </p:nvSpPr>
@@ -8975,7 +9150,7 @@
       </p:sp>
       <p:sp>
         <p:nvSpPr>
-          <p:cNvPr id="62" name="TextBox 61"/>
+          <p:cNvPr id="67" name="TextBox 66"/>
           <p:cNvSpPr txBox="1"/>
           <p:nvPr/>
         </p:nvSpPr>
@@ -9010,7 +9185,7 @@
       </p:sp>
       <p:sp>
         <p:nvSpPr>
-          <p:cNvPr id="63" name="Rounded Rectangle 62"/>
+          <p:cNvPr id="68" name="Rounded Rectangle 67"/>
           <p:cNvSpPr/>
           <p:nvPr/>
         </p:nvSpPr>
@@ -9056,7 +9231,7 @@
       </p:sp>
       <p:sp>
         <p:nvSpPr>
-          <p:cNvPr id="64" name="TextBox 63"/>
+          <p:cNvPr id="69" name="TextBox 68"/>
           <p:cNvSpPr txBox="1"/>
           <p:nvPr/>
         </p:nvSpPr>
@@ -9091,7 +9266,7 @@
       </p:sp>
       <p:sp>
         <p:nvSpPr>
-          <p:cNvPr id="65" name="Rectangle 64"/>
+          <p:cNvPr id="70" name="Rectangle 69"/>
           <p:cNvSpPr/>
           <p:nvPr/>
         </p:nvSpPr>
@@ -9135,7 +9310,7 @@
       </p:sp>
       <p:sp>
         <p:nvSpPr>
-          <p:cNvPr id="66" name="TextBox 65"/>
+          <p:cNvPr id="71" name="TextBox 70"/>
           <p:cNvSpPr txBox="1"/>
           <p:nvPr/>
         </p:nvSpPr>
@@ -9170,7 +9345,7 @@
       </p:sp>
       <p:sp>
         <p:nvSpPr>
-          <p:cNvPr id="67" name="TextBox 66"/>
+          <p:cNvPr id="72" name="TextBox 71"/>
           <p:cNvSpPr txBox="1"/>
           <p:nvPr/>
         </p:nvSpPr>

</xml_diff>